<commit_message>
Add Google Slides access on the course website and include presentation assets.
This publishes a direct presentation link with QR code on the GitHub Pages front page and stores the related lecture files in the repository for easier sharing.

Made-with: Cursor
</commit_message>
<xml_diff>
--- a/presentasjoner/AI_og_Helse_2x45min_klinisk_forelesning.pptx
+++ b/presentasjoner/AI_og_Helse_2x45min_klinisk_forelesning.pptx
@@ -5,66 +5,66 @@
     <p:sldMasterId id="2147483648" r:id="rId1"/>
   </p:sldMasterIdLst>
   <p:sldIdLst>
-    <p:sldId id="256" r:id="rId7"/>
-    <p:sldId id="257" r:id="rId8"/>
-    <p:sldId id="258" r:id="rId9"/>
-    <p:sldId id="259" r:id="rId10"/>
-    <p:sldId id="260" r:id="rId11"/>
-    <p:sldId id="261" r:id="rId12"/>
-    <p:sldId id="262" r:id="rId13"/>
-    <p:sldId id="263" r:id="rId14"/>
-    <p:sldId id="264" r:id="rId15"/>
-    <p:sldId id="265" r:id="rId16"/>
-    <p:sldId id="266" r:id="rId17"/>
-    <p:sldId id="267" r:id="rId18"/>
-    <p:sldId id="268" r:id="rId19"/>
-    <p:sldId id="269" r:id="rId20"/>
-    <p:sldId id="270" r:id="rId21"/>
-    <p:sldId id="271" r:id="rId22"/>
-    <p:sldId id="272" r:id="rId23"/>
-    <p:sldId id="273" r:id="rId24"/>
-    <p:sldId id="274" r:id="rId25"/>
-    <p:sldId id="275" r:id="rId26"/>
-    <p:sldId id="276" r:id="rId27"/>
-    <p:sldId id="277" r:id="rId28"/>
-    <p:sldId id="278" r:id="rId29"/>
-    <p:sldId id="279" r:id="rId30"/>
-    <p:sldId id="280" r:id="rId31"/>
-    <p:sldId id="281" r:id="rId32"/>
-    <p:sldId id="282" r:id="rId33"/>
-    <p:sldId id="283" r:id="rId34"/>
-    <p:sldId id="284" r:id="rId35"/>
-    <p:sldId id="285" r:id="rId36"/>
-    <p:sldId id="286" r:id="rId37"/>
-    <p:sldId id="287" r:id="rId38"/>
-    <p:sldId id="288" r:id="rId39"/>
-    <p:sldId id="289" r:id="rId40"/>
-    <p:sldId id="290" r:id="rId41"/>
-    <p:sldId id="291" r:id="rId42"/>
-    <p:sldId id="292" r:id="rId43"/>
-    <p:sldId id="293" r:id="rId44"/>
-    <p:sldId id="294" r:id="rId45"/>
-    <p:sldId id="295" r:id="rId46"/>
-    <p:sldId id="296" r:id="rId47"/>
-    <p:sldId id="297" r:id="rId48"/>
-    <p:sldId id="298" r:id="rId49"/>
-    <p:sldId id="299" r:id="rId50"/>
-    <p:sldId id="300" r:id="rId51"/>
-    <p:sldId id="301" r:id="rId52"/>
-    <p:sldId id="302" r:id="rId53"/>
-    <p:sldId id="303" r:id="rId54"/>
-    <p:sldId id="304" r:id="rId55"/>
-    <p:sldId id="305" r:id="rId56"/>
-    <p:sldId id="306" r:id="rId57"/>
-    <p:sldId id="307" r:id="rId58"/>
-    <p:sldId id="308" r:id="rId59"/>
-    <p:sldId id="309" r:id="rId60"/>
-    <p:sldId id="310" r:id="rId61"/>
-    <p:sldId id="311" r:id="rId62"/>
-    <p:sldId id="312" r:id="rId63"/>
-    <p:sldId id="313" r:id="rId64"/>
+    <p:sldId id="256" r:id="rId2"/>
+    <p:sldId id="257" r:id="rId3"/>
+    <p:sldId id="258" r:id="rId4"/>
+    <p:sldId id="259" r:id="rId5"/>
+    <p:sldId id="260" r:id="rId6"/>
+    <p:sldId id="261" r:id="rId7"/>
+    <p:sldId id="262" r:id="rId8"/>
+    <p:sldId id="263" r:id="rId9"/>
+    <p:sldId id="264" r:id="rId10"/>
+    <p:sldId id="265" r:id="rId11"/>
+    <p:sldId id="266" r:id="rId12"/>
+    <p:sldId id="267" r:id="rId13"/>
+    <p:sldId id="268" r:id="rId14"/>
+    <p:sldId id="269" r:id="rId15"/>
+    <p:sldId id="270" r:id="rId16"/>
+    <p:sldId id="271" r:id="rId17"/>
+    <p:sldId id="272" r:id="rId18"/>
+    <p:sldId id="273" r:id="rId19"/>
+    <p:sldId id="274" r:id="rId20"/>
+    <p:sldId id="275" r:id="rId21"/>
+    <p:sldId id="276" r:id="rId22"/>
+    <p:sldId id="277" r:id="rId23"/>
+    <p:sldId id="278" r:id="rId24"/>
+    <p:sldId id="279" r:id="rId25"/>
+    <p:sldId id="280" r:id="rId26"/>
+    <p:sldId id="281" r:id="rId27"/>
+    <p:sldId id="282" r:id="rId28"/>
+    <p:sldId id="283" r:id="rId29"/>
+    <p:sldId id="284" r:id="rId30"/>
+    <p:sldId id="285" r:id="rId31"/>
+    <p:sldId id="286" r:id="rId32"/>
+    <p:sldId id="287" r:id="rId33"/>
+    <p:sldId id="288" r:id="rId34"/>
+    <p:sldId id="289" r:id="rId35"/>
+    <p:sldId id="290" r:id="rId36"/>
+    <p:sldId id="291" r:id="rId37"/>
+    <p:sldId id="292" r:id="rId38"/>
+    <p:sldId id="293" r:id="rId39"/>
+    <p:sldId id="294" r:id="rId40"/>
+    <p:sldId id="295" r:id="rId41"/>
+    <p:sldId id="296" r:id="rId42"/>
+    <p:sldId id="297" r:id="rId43"/>
+    <p:sldId id="298" r:id="rId44"/>
+    <p:sldId id="299" r:id="rId45"/>
+    <p:sldId id="300" r:id="rId46"/>
+    <p:sldId id="301" r:id="rId47"/>
+    <p:sldId id="302" r:id="rId48"/>
+    <p:sldId id="303" r:id="rId49"/>
+    <p:sldId id="304" r:id="rId50"/>
+    <p:sldId id="305" r:id="rId51"/>
+    <p:sldId id="306" r:id="rId52"/>
+    <p:sldId id="307" r:id="rId53"/>
+    <p:sldId id="308" r:id="rId54"/>
+    <p:sldId id="309" r:id="rId55"/>
+    <p:sldId id="310" r:id="rId56"/>
+    <p:sldId id="311" r:id="rId57"/>
+    <p:sldId id="312" r:id="rId58"/>
+    <p:sldId id="313" r:id="rId59"/>
   </p:sldIdLst>
-  <p:sldSz cx="12191695" cy="6858000" type="screen4x3"/>
+  <p:sldSz cx="12192000" cy="6858000"/>
   <p:notesSz cx="6858000" cy="9144000"/>
   <p:defaultTextStyle>
     <a:defPPr>
@@ -161,6 +161,22 @@
       </a:defRPr>
     </a:lvl9pPr>
   </p:defaultTextStyle>
+  <p:extLst>
+    <p:ext uri="{EFAFB233-063F-42B5-8137-9DF3F51BA10A}">
+      <p15:sldGuideLst xmlns:p15="http://schemas.microsoft.com/office/powerpoint/2012/main">
+        <p15:guide id="1" orient="horz" pos="2160">
+          <p15:clr>
+            <a:srgbClr val="A4A3A4"/>
+          </p15:clr>
+        </p15:guide>
+        <p15:guide id="2" pos="2880">
+          <p15:clr>
+            <a:srgbClr val="A4A3A4"/>
+          </p15:clr>
+        </p15:guide>
+      </p15:sldGuideLst>
+    </p:ext>
+  </p:extLst>
 </p:presentation>
 </file>
 
@@ -202,10 +218,9 @@
           <a:lstStyle/>
           <a:p>
             <a:r>
-              <a:rPr lang="en-US" smtClean="0"/>
+              <a:rPr lang="en-US"/>
               <a:t>Click to edit Master title style</a:t>
             </a:r>
-            <a:endParaRPr lang="en-US"/>
           </a:p>
         </p:txBody>
       </p:sp>
@@ -321,10 +336,9 @@
           </a:lstStyle>
           <a:p>
             <a:r>
-              <a:rPr lang="en-US" smtClean="0"/>
+              <a:rPr lang="en-US"/>
               <a:t>Click to edit Master subtitle style</a:t>
             </a:r>
-            <a:endParaRPr lang="en-US"/>
           </a:p>
         </p:txBody>
       </p:sp>
@@ -345,7 +359,7 @@
           <a:p>
             <a:fld id="{5BCAD085-E8A6-8845-BD4E-CB4CCA059FC4}" type="datetimeFigureOut">
               <a:rPr lang="en-US" smtClean="0"/>
-              <a:t>1/27/13</a:t>
+              <a:t>3/31/26</a:t>
             </a:fld>
             <a:endParaRPr lang="en-US"/>
           </a:p>
@@ -439,10 +453,9 @@
           <a:lstStyle/>
           <a:p>
             <a:r>
-              <a:rPr lang="en-US" smtClean="0"/>
+              <a:rPr lang="en-US"/>
               <a:t>Click to edit Master title style</a:t>
             </a:r>
-            <a:endParaRPr lang="en-US"/>
           </a:p>
         </p:txBody>
       </p:sp>
@@ -463,38 +476,37 @@
           <a:p>
             <a:pPr lvl="0"/>
             <a:r>
-              <a:rPr lang="en-US" smtClean="0"/>
+              <a:rPr lang="en-US"/>
               <a:t>Click to edit Master text styles</a:t>
             </a:r>
           </a:p>
           <a:p>
             <a:pPr lvl="1"/>
             <a:r>
-              <a:rPr lang="en-US" smtClean="0"/>
+              <a:rPr lang="en-US"/>
               <a:t>Second level</a:t>
             </a:r>
           </a:p>
           <a:p>
             <a:pPr lvl="2"/>
             <a:r>
-              <a:rPr lang="en-US" smtClean="0"/>
+              <a:rPr lang="en-US"/>
               <a:t>Third level</a:t>
             </a:r>
           </a:p>
           <a:p>
             <a:pPr lvl="3"/>
             <a:r>
-              <a:rPr lang="en-US" smtClean="0"/>
+              <a:rPr lang="en-US"/>
               <a:t>Fourth level</a:t>
             </a:r>
           </a:p>
           <a:p>
             <a:pPr lvl="4"/>
             <a:r>
-              <a:rPr lang="en-US" smtClean="0"/>
+              <a:rPr lang="en-US"/>
               <a:t>Fifth level</a:t>
             </a:r>
-            <a:endParaRPr lang="en-US"/>
           </a:p>
         </p:txBody>
       </p:sp>
@@ -515,7 +527,7 @@
           <a:p>
             <a:fld id="{5BCAD085-E8A6-8845-BD4E-CB4CCA059FC4}" type="datetimeFigureOut">
               <a:rPr lang="en-US" smtClean="0"/>
-              <a:t>1/27/13</a:t>
+              <a:t>3/31/26</a:t>
             </a:fld>
             <a:endParaRPr lang="en-US"/>
           </a:p>
@@ -614,10 +626,9 @@
           <a:lstStyle/>
           <a:p>
             <a:r>
-              <a:rPr lang="en-US" smtClean="0"/>
+              <a:rPr lang="en-US"/>
               <a:t>Click to edit Master title style</a:t>
             </a:r>
-            <a:endParaRPr lang="en-US"/>
           </a:p>
         </p:txBody>
       </p:sp>
@@ -643,38 +654,37 @@
           <a:p>
             <a:pPr lvl="0"/>
             <a:r>
-              <a:rPr lang="en-US" smtClean="0"/>
+              <a:rPr lang="en-US"/>
               <a:t>Click to edit Master text styles</a:t>
             </a:r>
           </a:p>
           <a:p>
             <a:pPr lvl="1"/>
             <a:r>
-              <a:rPr lang="en-US" smtClean="0"/>
+              <a:rPr lang="en-US"/>
               <a:t>Second level</a:t>
             </a:r>
           </a:p>
           <a:p>
             <a:pPr lvl="2"/>
             <a:r>
-              <a:rPr lang="en-US" smtClean="0"/>
+              <a:rPr lang="en-US"/>
               <a:t>Third level</a:t>
             </a:r>
           </a:p>
           <a:p>
             <a:pPr lvl="3"/>
             <a:r>
-              <a:rPr lang="en-US" smtClean="0"/>
+              <a:rPr lang="en-US"/>
               <a:t>Fourth level</a:t>
             </a:r>
           </a:p>
           <a:p>
             <a:pPr lvl="4"/>
             <a:r>
-              <a:rPr lang="en-US" smtClean="0"/>
+              <a:rPr lang="en-US"/>
               <a:t>Fifth level</a:t>
             </a:r>
-            <a:endParaRPr lang="en-US"/>
           </a:p>
         </p:txBody>
       </p:sp>
@@ -695,7 +705,7 @@
           <a:p>
             <a:fld id="{5BCAD085-E8A6-8845-BD4E-CB4CCA059FC4}" type="datetimeFigureOut">
               <a:rPr lang="en-US" smtClean="0"/>
-              <a:t>1/27/13</a:t>
+              <a:t>3/31/26</a:t>
             </a:fld>
             <a:endParaRPr lang="en-US"/>
           </a:p>
@@ -789,10 +799,9 @@
           <a:lstStyle/>
           <a:p>
             <a:r>
-              <a:rPr lang="en-US" smtClean="0"/>
+              <a:rPr lang="en-US"/>
               <a:t>Click to edit Master title style</a:t>
             </a:r>
-            <a:endParaRPr lang="en-US"/>
           </a:p>
         </p:txBody>
       </p:sp>
@@ -813,38 +822,37 @@
           <a:p>
             <a:pPr lvl="0"/>
             <a:r>
-              <a:rPr lang="en-US" smtClean="0"/>
+              <a:rPr lang="en-US"/>
               <a:t>Click to edit Master text styles</a:t>
             </a:r>
           </a:p>
           <a:p>
             <a:pPr lvl="1"/>
             <a:r>
-              <a:rPr lang="en-US" smtClean="0"/>
+              <a:rPr lang="en-US"/>
               <a:t>Second level</a:t>
             </a:r>
           </a:p>
           <a:p>
             <a:pPr lvl="2"/>
             <a:r>
-              <a:rPr lang="en-US" smtClean="0"/>
+              <a:rPr lang="en-US"/>
               <a:t>Third level</a:t>
             </a:r>
           </a:p>
           <a:p>
             <a:pPr lvl="3"/>
             <a:r>
-              <a:rPr lang="en-US" smtClean="0"/>
+              <a:rPr lang="en-US"/>
               <a:t>Fourth level</a:t>
             </a:r>
           </a:p>
           <a:p>
             <a:pPr lvl="4"/>
             <a:r>
-              <a:rPr lang="en-US" smtClean="0"/>
+              <a:rPr lang="en-US"/>
               <a:t>Fifth level</a:t>
             </a:r>
-            <a:endParaRPr lang="en-US"/>
           </a:p>
         </p:txBody>
       </p:sp>
@@ -865,7 +873,7 @@
           <a:p>
             <a:fld id="{5BCAD085-E8A6-8845-BD4E-CB4CCA059FC4}" type="datetimeFigureOut">
               <a:rPr lang="en-US" smtClean="0"/>
-              <a:t>1/27/13</a:t>
+              <a:t>3/31/26</a:t>
             </a:fld>
             <a:endParaRPr lang="en-US"/>
           </a:p>
@@ -968,10 +976,9 @@
           </a:lstStyle>
           <a:p>
             <a:r>
-              <a:rPr lang="en-US" smtClean="0"/>
+              <a:rPr lang="en-US"/>
               <a:t>Click to edit Master title style</a:t>
             </a:r>
-            <a:endParaRPr lang="en-US"/>
           </a:p>
         </p:txBody>
       </p:sp>
@@ -1088,7 +1095,7 @@
           <a:p>
             <a:pPr lvl="0"/>
             <a:r>
-              <a:rPr lang="en-US" smtClean="0"/>
+              <a:rPr lang="en-US"/>
               <a:t>Click to edit Master text styles</a:t>
             </a:r>
           </a:p>
@@ -1111,7 +1118,7 @@
           <a:p>
             <a:fld id="{5BCAD085-E8A6-8845-BD4E-CB4CCA059FC4}" type="datetimeFigureOut">
               <a:rPr lang="en-US" smtClean="0"/>
-              <a:t>1/27/13</a:t>
+              <a:t>3/31/26</a:t>
             </a:fld>
             <a:endParaRPr lang="en-US"/>
           </a:p>
@@ -1205,10 +1212,9 @@
           <a:lstStyle/>
           <a:p>
             <a:r>
-              <a:rPr lang="en-US" smtClean="0"/>
+              <a:rPr lang="en-US"/>
               <a:t>Click to edit Master title style</a:t>
             </a:r>
-            <a:endParaRPr lang="en-US"/>
           </a:p>
         </p:txBody>
       </p:sp>
@@ -1262,38 +1268,37 @@
           <a:p>
             <a:pPr lvl="0"/>
             <a:r>
-              <a:rPr lang="en-US" smtClean="0"/>
+              <a:rPr lang="en-US"/>
               <a:t>Click to edit Master text styles</a:t>
             </a:r>
           </a:p>
           <a:p>
             <a:pPr lvl="1"/>
             <a:r>
-              <a:rPr lang="en-US" smtClean="0"/>
+              <a:rPr lang="en-US"/>
               <a:t>Second level</a:t>
             </a:r>
           </a:p>
           <a:p>
             <a:pPr lvl="2"/>
             <a:r>
-              <a:rPr lang="en-US" smtClean="0"/>
+              <a:rPr lang="en-US"/>
               <a:t>Third level</a:t>
             </a:r>
           </a:p>
           <a:p>
             <a:pPr lvl="3"/>
             <a:r>
-              <a:rPr lang="en-US" smtClean="0"/>
+              <a:rPr lang="en-US"/>
               <a:t>Fourth level</a:t>
             </a:r>
           </a:p>
           <a:p>
             <a:pPr lvl="4"/>
             <a:r>
-              <a:rPr lang="en-US" smtClean="0"/>
+              <a:rPr lang="en-US"/>
               <a:t>Fifth level</a:t>
             </a:r>
-            <a:endParaRPr lang="en-US"/>
           </a:p>
         </p:txBody>
       </p:sp>
@@ -1347,38 +1352,37 @@
           <a:p>
             <a:pPr lvl="0"/>
             <a:r>
-              <a:rPr lang="en-US" smtClean="0"/>
+              <a:rPr lang="en-US"/>
               <a:t>Click to edit Master text styles</a:t>
             </a:r>
           </a:p>
           <a:p>
             <a:pPr lvl="1"/>
             <a:r>
-              <a:rPr lang="en-US" smtClean="0"/>
+              <a:rPr lang="en-US"/>
               <a:t>Second level</a:t>
             </a:r>
           </a:p>
           <a:p>
             <a:pPr lvl="2"/>
             <a:r>
-              <a:rPr lang="en-US" smtClean="0"/>
+              <a:rPr lang="en-US"/>
               <a:t>Third level</a:t>
             </a:r>
           </a:p>
           <a:p>
             <a:pPr lvl="3"/>
             <a:r>
-              <a:rPr lang="en-US" smtClean="0"/>
+              <a:rPr lang="en-US"/>
               <a:t>Fourth level</a:t>
             </a:r>
           </a:p>
           <a:p>
             <a:pPr lvl="4"/>
             <a:r>
-              <a:rPr lang="en-US" smtClean="0"/>
+              <a:rPr lang="en-US"/>
               <a:t>Fifth level</a:t>
             </a:r>
-            <a:endParaRPr lang="en-US"/>
           </a:p>
         </p:txBody>
       </p:sp>
@@ -1399,7 +1403,7 @@
           <a:p>
             <a:fld id="{5BCAD085-E8A6-8845-BD4E-CB4CCA059FC4}" type="datetimeFigureOut">
               <a:rPr lang="en-US" smtClean="0"/>
-              <a:t>1/27/13</a:t>
+              <a:t>3/31/26</a:t>
             </a:fld>
             <a:endParaRPr lang="en-US"/>
           </a:p>
@@ -1497,10 +1501,9 @@
           </a:lstStyle>
           <a:p>
             <a:r>
-              <a:rPr lang="en-US" smtClean="0"/>
+              <a:rPr lang="en-US"/>
               <a:t>Click to edit Master title style</a:t>
             </a:r>
-            <a:endParaRPr lang="en-US"/>
           </a:p>
         </p:txBody>
       </p:sp>
@@ -1563,7 +1566,7 @@
           <a:p>
             <a:pPr lvl="0"/>
             <a:r>
-              <a:rPr lang="en-US" smtClean="0"/>
+              <a:rPr lang="en-US"/>
               <a:t>Click to edit Master text styles</a:t>
             </a:r>
           </a:p>
@@ -1619,38 +1622,37 @@
           <a:p>
             <a:pPr lvl="0"/>
             <a:r>
-              <a:rPr lang="en-US" smtClean="0"/>
+              <a:rPr lang="en-US"/>
               <a:t>Click to edit Master text styles</a:t>
             </a:r>
           </a:p>
           <a:p>
             <a:pPr lvl="1"/>
             <a:r>
-              <a:rPr lang="en-US" smtClean="0"/>
+              <a:rPr lang="en-US"/>
               <a:t>Second level</a:t>
             </a:r>
           </a:p>
           <a:p>
             <a:pPr lvl="2"/>
             <a:r>
-              <a:rPr lang="en-US" smtClean="0"/>
+              <a:rPr lang="en-US"/>
               <a:t>Third level</a:t>
             </a:r>
           </a:p>
           <a:p>
             <a:pPr lvl="3"/>
             <a:r>
-              <a:rPr lang="en-US" smtClean="0"/>
+              <a:rPr lang="en-US"/>
               <a:t>Fourth level</a:t>
             </a:r>
           </a:p>
           <a:p>
             <a:pPr lvl="4"/>
             <a:r>
-              <a:rPr lang="en-US" smtClean="0"/>
+              <a:rPr lang="en-US"/>
               <a:t>Fifth level</a:t>
             </a:r>
-            <a:endParaRPr lang="en-US"/>
           </a:p>
         </p:txBody>
       </p:sp>
@@ -1713,7 +1715,7 @@
           <a:p>
             <a:pPr lvl="0"/>
             <a:r>
-              <a:rPr lang="en-US" smtClean="0"/>
+              <a:rPr lang="en-US"/>
               <a:t>Click to edit Master text styles</a:t>
             </a:r>
           </a:p>
@@ -1769,38 +1771,37 @@
           <a:p>
             <a:pPr lvl="0"/>
             <a:r>
-              <a:rPr lang="en-US" smtClean="0"/>
+              <a:rPr lang="en-US"/>
               <a:t>Click to edit Master text styles</a:t>
             </a:r>
           </a:p>
           <a:p>
             <a:pPr lvl="1"/>
             <a:r>
-              <a:rPr lang="en-US" smtClean="0"/>
+              <a:rPr lang="en-US"/>
               <a:t>Second level</a:t>
             </a:r>
           </a:p>
           <a:p>
             <a:pPr lvl="2"/>
             <a:r>
-              <a:rPr lang="en-US" smtClean="0"/>
+              <a:rPr lang="en-US"/>
               <a:t>Third level</a:t>
             </a:r>
           </a:p>
           <a:p>
             <a:pPr lvl="3"/>
             <a:r>
-              <a:rPr lang="en-US" smtClean="0"/>
+              <a:rPr lang="en-US"/>
               <a:t>Fourth level</a:t>
             </a:r>
           </a:p>
           <a:p>
             <a:pPr lvl="4"/>
             <a:r>
-              <a:rPr lang="en-US" smtClean="0"/>
+              <a:rPr lang="en-US"/>
               <a:t>Fifth level</a:t>
             </a:r>
-            <a:endParaRPr lang="en-US"/>
           </a:p>
         </p:txBody>
       </p:sp>
@@ -1821,7 +1822,7 @@
           <a:p>
             <a:fld id="{5BCAD085-E8A6-8845-BD4E-CB4CCA059FC4}" type="datetimeFigureOut">
               <a:rPr lang="en-US" smtClean="0"/>
-              <a:t>1/27/13</a:t>
+              <a:t>3/31/26</a:t>
             </a:fld>
             <a:endParaRPr lang="en-US"/>
           </a:p>
@@ -1915,10 +1916,9 @@
           <a:lstStyle/>
           <a:p>
             <a:r>
-              <a:rPr lang="en-US" smtClean="0"/>
+              <a:rPr lang="en-US"/>
               <a:t>Click to edit Master title style</a:t>
             </a:r>
-            <a:endParaRPr lang="en-US"/>
           </a:p>
         </p:txBody>
       </p:sp>
@@ -1939,7 +1939,7 @@
           <a:p>
             <a:fld id="{5BCAD085-E8A6-8845-BD4E-CB4CCA059FC4}" type="datetimeFigureOut">
               <a:rPr lang="en-US" smtClean="0"/>
-              <a:t>1/27/13</a:t>
+              <a:t>3/31/26</a:t>
             </a:fld>
             <a:endParaRPr lang="en-US"/>
           </a:p>
@@ -2034,7 +2034,7 @@
           <a:p>
             <a:fld id="{5BCAD085-E8A6-8845-BD4E-CB4CCA059FC4}" type="datetimeFigureOut">
               <a:rPr lang="en-US" smtClean="0"/>
-              <a:t>1/27/13</a:t>
+              <a:t>3/31/26</a:t>
             </a:fld>
             <a:endParaRPr lang="en-US"/>
           </a:p>
@@ -2137,10 +2137,9 @@
           </a:lstStyle>
           <a:p>
             <a:r>
-              <a:rPr lang="en-US" smtClean="0"/>
+              <a:rPr lang="en-US"/>
               <a:t>Click to edit Master title style</a:t>
             </a:r>
-            <a:endParaRPr lang="en-US"/>
           </a:p>
         </p:txBody>
       </p:sp>
@@ -2194,38 +2193,37 @@
           <a:p>
             <a:pPr lvl="0"/>
             <a:r>
-              <a:rPr lang="en-US" smtClean="0"/>
+              <a:rPr lang="en-US"/>
               <a:t>Click to edit Master text styles</a:t>
             </a:r>
           </a:p>
           <a:p>
             <a:pPr lvl="1"/>
             <a:r>
-              <a:rPr lang="en-US" smtClean="0"/>
+              <a:rPr lang="en-US"/>
               <a:t>Second level</a:t>
             </a:r>
           </a:p>
           <a:p>
             <a:pPr lvl="2"/>
             <a:r>
-              <a:rPr lang="en-US" smtClean="0"/>
+              <a:rPr lang="en-US"/>
               <a:t>Third level</a:t>
             </a:r>
           </a:p>
           <a:p>
             <a:pPr lvl="3"/>
             <a:r>
-              <a:rPr lang="en-US" smtClean="0"/>
+              <a:rPr lang="en-US"/>
               <a:t>Fourth level</a:t>
             </a:r>
           </a:p>
           <a:p>
             <a:pPr lvl="4"/>
             <a:r>
-              <a:rPr lang="en-US" smtClean="0"/>
+              <a:rPr lang="en-US"/>
               <a:t>Fifth level</a:t>
             </a:r>
-            <a:endParaRPr lang="en-US"/>
           </a:p>
         </p:txBody>
       </p:sp>
@@ -2288,7 +2286,7 @@
           <a:p>
             <a:pPr lvl="0"/>
             <a:r>
-              <a:rPr lang="en-US" smtClean="0"/>
+              <a:rPr lang="en-US"/>
               <a:t>Click to edit Master text styles</a:t>
             </a:r>
           </a:p>
@@ -2311,7 +2309,7 @@
           <a:p>
             <a:fld id="{5BCAD085-E8A6-8845-BD4E-CB4CCA059FC4}" type="datetimeFigureOut">
               <a:rPr lang="en-US" smtClean="0"/>
-              <a:t>1/27/13</a:t>
+              <a:t>3/31/26</a:t>
             </a:fld>
             <a:endParaRPr lang="en-US"/>
           </a:p>
@@ -2414,10 +2412,9 @@
           </a:lstStyle>
           <a:p>
             <a:r>
-              <a:rPr lang="en-US" smtClean="0"/>
+              <a:rPr lang="en-US"/>
               <a:t>Click to edit Master title style</a:t>
             </a:r>
-            <a:endParaRPr lang="en-US"/>
           </a:p>
         </p:txBody>
       </p:sp>
@@ -2541,7 +2538,7 @@
           <a:p>
             <a:pPr lvl="0"/>
             <a:r>
-              <a:rPr lang="en-US" smtClean="0"/>
+              <a:rPr lang="en-US"/>
               <a:t>Click to edit Master text styles</a:t>
             </a:r>
           </a:p>
@@ -2564,7 +2561,7 @@
           <a:p>
             <a:fld id="{5BCAD085-E8A6-8845-BD4E-CB4CCA059FC4}" type="datetimeFigureOut">
               <a:rPr lang="en-US" smtClean="0"/>
-              <a:t>1/27/13</a:t>
+              <a:t>3/31/26</a:t>
             </a:fld>
             <a:endParaRPr lang="en-US"/>
           </a:p>
@@ -2673,10 +2670,9 @@
           <a:lstStyle/>
           <a:p>
             <a:r>
-              <a:rPr lang="en-US" smtClean="0"/>
+              <a:rPr lang="en-US"/>
               <a:t>Click to edit Master title style</a:t>
             </a:r>
-            <a:endParaRPr lang="en-US"/>
           </a:p>
         </p:txBody>
       </p:sp>
@@ -2707,38 +2703,37 @@
           <a:p>
             <a:pPr lvl="0"/>
             <a:r>
-              <a:rPr lang="en-US" smtClean="0"/>
+              <a:rPr lang="en-US"/>
               <a:t>Click to edit Master text styles</a:t>
             </a:r>
           </a:p>
           <a:p>
             <a:pPr lvl="1"/>
             <a:r>
-              <a:rPr lang="en-US" smtClean="0"/>
+              <a:rPr lang="en-US"/>
               <a:t>Second level</a:t>
             </a:r>
           </a:p>
           <a:p>
             <a:pPr lvl="2"/>
             <a:r>
-              <a:rPr lang="en-US" smtClean="0"/>
+              <a:rPr lang="en-US"/>
               <a:t>Third level</a:t>
             </a:r>
           </a:p>
           <a:p>
             <a:pPr lvl="3"/>
             <a:r>
-              <a:rPr lang="en-US" smtClean="0"/>
+              <a:rPr lang="en-US"/>
               <a:t>Fourth level</a:t>
             </a:r>
           </a:p>
           <a:p>
             <a:pPr lvl="4"/>
             <a:r>
-              <a:rPr lang="en-US" smtClean="0"/>
+              <a:rPr lang="en-US"/>
               <a:t>Fifth level</a:t>
             </a:r>
-            <a:endParaRPr lang="en-US"/>
           </a:p>
         </p:txBody>
       </p:sp>
@@ -2777,7 +2772,7 @@
           <a:p>
             <a:fld id="{5BCAD085-E8A6-8845-BD4E-CB4CCA059FC4}" type="datetimeFigureOut">
               <a:rPr lang="en-US" smtClean="0"/>
-              <a:t>1/27/13</a:t>
+              <a:t>3/31/26</a:t>
             </a:fld>
             <a:endParaRPr lang="en-US"/>
           </a:p>
@@ -3136,7 +3131,7 @@
 </file>
 
 <file path=ppt/slides/slide1.xml><?xml version="1.0" encoding="utf-8"?>
-<p:sld xmlns:a="http://schemas.openxmlformats.org/drawingml/2006/main" xmlns:p="http://schemas.openxmlformats.org/presentationml/2006/main" xmlns:r="http://schemas.openxmlformats.org/officeDocument/2006/relationships">
+<p:sld xmlns:a="http://schemas.openxmlformats.org/drawingml/2006/main" xmlns:r="http://schemas.openxmlformats.org/officeDocument/2006/relationships" xmlns:p="http://schemas.openxmlformats.org/presentationml/2006/main">
   <p:cSld>
     <p:bg>
       <p:bgPr>
@@ -3152,7 +3147,14 @@
         <p:cNvGrpSpPr/>
         <p:nvPr/>
       </p:nvGrpSpPr>
-      <p:grpSpPr/>
+      <p:grpSpPr>
+        <a:xfrm>
+          <a:off x="0" y="0"/>
+          <a:ext cx="0" cy="0"/>
+          <a:chOff x="0" y="0"/>
+          <a:chExt cx="0" cy="0"/>
+        </a:xfrm>
+      </p:grpSpPr>
       <p:sp>
         <p:nvSpPr>
           <p:cNvPr id="2" name="Rectangle 1"/>
@@ -3193,6 +3195,7 @@
           <a:lstStyle/>
           <a:p>
             <a:pPr algn="ctr"/>
+            <a:endParaRPr/>
           </a:p>
         </p:txBody>
       </p:sp>
@@ -3238,6 +3241,7 @@
           <a:lstStyle/>
           <a:p>
             <a:pPr algn="ctr"/>
+            <a:endParaRPr/>
           </a:p>
         </p:txBody>
       </p:sp>
@@ -3319,7 +3323,7 @@
         <p:spPr>
           <a:xfrm>
             <a:off x="822960" y="3063240"/>
-            <a:ext cx="5669280" cy="1188720"/>
+            <a:ext cx="6335902" cy="707886"/>
           </a:xfrm>
           <a:prstGeom prst="rect">
             <a:avLst/>
@@ -3333,13 +3337,192 @@
           <a:lstStyle/>
           <a:p>
             <a:r>
-              <a:rPr sz="2000">
+              <a:rPr sz="2000" dirty="0">
                 <a:solidFill>
                   <a:srgbClr val="5D524B"/>
                 </a:solidFill>
                 <a:latin typeface="Aptos"/>
               </a:rPr>
-              <a:t>To forelesningsøkter à 45 minutter for klinisk målgruppe med liten eller moderat teknisk bakgrunn.</a:t>
+              <a:t>To </a:t>
+            </a:r>
+            <a:r>
+              <a:rPr sz="2000" dirty="0" err="1">
+                <a:solidFill>
+                  <a:srgbClr val="5D524B"/>
+                </a:solidFill>
+                <a:latin typeface="Aptos"/>
+              </a:rPr>
+              <a:t>forelesningsøkter</a:t>
+            </a:r>
+            <a:r>
+              <a:rPr sz="2000" dirty="0">
+                <a:solidFill>
+                  <a:srgbClr val="5D524B"/>
+                </a:solidFill>
+                <a:latin typeface="Aptos"/>
+              </a:rPr>
+              <a:t> à 45 </a:t>
+            </a:r>
+            <a:r>
+              <a:rPr sz="2000" dirty="0" err="1">
+                <a:solidFill>
+                  <a:srgbClr val="5D524B"/>
+                </a:solidFill>
+                <a:latin typeface="Aptos"/>
+              </a:rPr>
+              <a:t>minutter</a:t>
+            </a:r>
+            <a:r>
+              <a:rPr sz="2000" dirty="0">
+                <a:solidFill>
+                  <a:srgbClr val="5D524B"/>
+                </a:solidFill>
+                <a:latin typeface="Aptos"/>
+              </a:rPr>
+              <a:t> for </a:t>
+            </a:r>
+            <a:r>
+              <a:rPr sz="2000" dirty="0" err="1">
+                <a:solidFill>
+                  <a:srgbClr val="5D524B"/>
+                </a:solidFill>
+                <a:latin typeface="Aptos"/>
+              </a:rPr>
+              <a:t>klinisk</a:t>
+            </a:r>
+            <a:r>
+              <a:rPr sz="2000" dirty="0">
+                <a:solidFill>
+                  <a:srgbClr val="5D524B"/>
+                </a:solidFill>
+                <a:latin typeface="Aptos"/>
+              </a:rPr>
+              <a:t> </a:t>
+            </a:r>
+            <a:r>
+              <a:rPr sz="2000" dirty="0" err="1">
+                <a:solidFill>
+                  <a:srgbClr val="5D524B"/>
+                </a:solidFill>
+                <a:latin typeface="Aptos"/>
+              </a:rPr>
+              <a:t>målgruppe</a:t>
+            </a:r>
+            <a:r>
+              <a:rPr sz="2000" dirty="0">
+                <a:solidFill>
+                  <a:srgbClr val="5D524B"/>
+                </a:solidFill>
+                <a:latin typeface="Aptos"/>
+              </a:rPr>
+              <a:t> </a:t>
+            </a:r>
+            <a:endParaRPr lang="nb-NO" sz="2000" dirty="0">
+              <a:solidFill>
+                <a:srgbClr val="5D524B"/>
+              </a:solidFill>
+              <a:latin typeface="Aptos"/>
+            </a:endParaRPr>
+          </a:p>
+          <a:p>
+            <a:r>
+              <a:rPr sz="2000" dirty="0">
+                <a:solidFill>
+                  <a:srgbClr val="5D524B"/>
+                </a:solidFill>
+                <a:latin typeface="Aptos"/>
+              </a:rPr>
+              <a:t>med </a:t>
+            </a:r>
+            <a:r>
+              <a:rPr sz="2000" dirty="0" err="1">
+                <a:solidFill>
+                  <a:srgbClr val="5D524B"/>
+                </a:solidFill>
+                <a:latin typeface="Aptos"/>
+              </a:rPr>
+              <a:t>liten</a:t>
+            </a:r>
+            <a:r>
+              <a:rPr sz="2000" dirty="0">
+                <a:solidFill>
+                  <a:srgbClr val="5D524B"/>
+                </a:solidFill>
+                <a:latin typeface="Aptos"/>
+              </a:rPr>
+              <a:t> </a:t>
+            </a:r>
+            <a:r>
+              <a:rPr sz="2000" dirty="0" err="1">
+                <a:solidFill>
+                  <a:srgbClr val="5D524B"/>
+                </a:solidFill>
+                <a:latin typeface="Aptos"/>
+              </a:rPr>
+              <a:t>eller</a:t>
+            </a:r>
+            <a:r>
+              <a:rPr sz="2000" dirty="0">
+                <a:solidFill>
+                  <a:srgbClr val="5D524B"/>
+                </a:solidFill>
+                <a:latin typeface="Aptos"/>
+              </a:rPr>
+              <a:t> </a:t>
+            </a:r>
+            <a:r>
+              <a:rPr sz="2000" dirty="0" err="1">
+                <a:solidFill>
+                  <a:srgbClr val="5D524B"/>
+                </a:solidFill>
+                <a:latin typeface="Aptos"/>
+              </a:rPr>
+              <a:t>moderat</a:t>
+            </a:r>
+            <a:r>
+              <a:rPr sz="2000" dirty="0">
+                <a:solidFill>
+                  <a:srgbClr val="5D524B"/>
+                </a:solidFill>
+                <a:latin typeface="Aptos"/>
+              </a:rPr>
+              <a:t> </a:t>
+            </a:r>
+            <a:r>
+              <a:rPr sz="2000" dirty="0" err="1">
+                <a:solidFill>
+                  <a:srgbClr val="5D524B"/>
+                </a:solidFill>
+                <a:latin typeface="Aptos"/>
+              </a:rPr>
+              <a:t>teknisk</a:t>
+            </a:r>
+            <a:r>
+              <a:rPr sz="2000" dirty="0">
+                <a:solidFill>
+                  <a:srgbClr val="5D524B"/>
+                </a:solidFill>
+                <a:latin typeface="Aptos"/>
+              </a:rPr>
+              <a:t> </a:t>
+            </a:r>
+            <a:r>
+              <a:rPr sz="2000" dirty="0" err="1">
+                <a:solidFill>
+                  <a:srgbClr val="5D524B"/>
+                </a:solidFill>
+                <a:latin typeface="Aptos"/>
+              </a:rPr>
+              <a:t>bakgrunn</a:t>
+            </a:r>
+            <a:r>
+              <a:rPr sz="2000" dirty="0">
+                <a:solidFill>
+                  <a:srgbClr val="5D524B"/>
+                </a:solidFill>
+                <a:latin typeface="Aptos"/>
+              </a:rPr>
+              <a:t>.</a:t>
             </a:r>
           </a:p>
         </p:txBody>
@@ -3422,6 +3605,25 @@
             </a:r>
           </a:p>
           <a:p>
+            <a:endParaRPr sz="1300" b="0">
+              <a:solidFill>
+                <a:srgbClr val="5D524B"/>
+              </a:solidFill>
+              <a:latin typeface="Aptos"/>
+            </a:endParaRPr>
+          </a:p>
+          <a:p>
+            <a:r>
+              <a:rPr sz="1500" b="1">
+                <a:solidFill>
+                  <a:srgbClr val="1F1A17"/>
+                </a:solidFill>
+                <a:latin typeface="Aptos"/>
+              </a:rPr>
+              <a:t>Format</a:t>
+            </a:r>
+          </a:p>
+          <a:p>
             <a:r>
               <a:rPr sz="1300" b="0">
                 <a:solidFill>
@@ -3429,41 +3631,16 @@
                 </a:solidFill>
                 <a:latin typeface="Aptos"/>
               </a:rPr>
-              <a:t/>
-            </a:r>
-          </a:p>
-          <a:p>
-            <a:r>
-              <a:rPr sz="1500" b="1">
-                <a:solidFill>
-                  <a:srgbClr val="1F1A17"/>
-                </a:solidFill>
-                <a:latin typeface="Aptos"/>
-              </a:rPr>
-              <a:t>Format</a:t>
-            </a:r>
-          </a:p>
-          <a:p>
-            <a:r>
-              <a:rPr sz="1300" b="0">
-                <a:solidFill>
-                  <a:srgbClr val="5D524B"/>
-                </a:solidFill>
-                <a:latin typeface="Aptos"/>
-              </a:rPr>
               <a:t>2 x 45 minutter</a:t>
             </a:r>
           </a:p>
           <a:p>
-            <a:r>
-              <a:rPr sz="1300" b="0">
-                <a:solidFill>
-                  <a:srgbClr val="5D524B"/>
-                </a:solidFill>
-                <a:latin typeface="Aptos"/>
-              </a:rPr>
-              <a:t/>
-            </a:r>
+            <a:endParaRPr sz="1300" b="0">
+              <a:solidFill>
+                <a:srgbClr val="5D524B"/>
+              </a:solidFill>
+              <a:latin typeface="Aptos"/>
+            </a:endParaRPr>
           </a:p>
           <a:p>
             <a:r>
@@ -3498,7 +3675,7 @@
 </file>
 
 <file path=ppt/slides/slide10.xml><?xml version="1.0" encoding="utf-8"?>
-<p:sld xmlns:a="http://schemas.openxmlformats.org/drawingml/2006/main" xmlns:p="http://schemas.openxmlformats.org/presentationml/2006/main" xmlns:r="http://schemas.openxmlformats.org/officeDocument/2006/relationships">
+<p:sld xmlns:a="http://schemas.openxmlformats.org/drawingml/2006/main" xmlns:r="http://schemas.openxmlformats.org/officeDocument/2006/relationships" xmlns:p="http://schemas.openxmlformats.org/presentationml/2006/main">
   <p:cSld>
     <p:bg>
       <p:bgPr>
@@ -3514,7 +3691,14 @@
         <p:cNvGrpSpPr/>
         <p:nvPr/>
       </p:nvGrpSpPr>
-      <p:grpSpPr/>
+      <p:grpSpPr>
+        <a:xfrm>
+          <a:off x="0" y="0"/>
+          <a:ext cx="0" cy="0"/>
+          <a:chOff x="0" y="0"/>
+          <a:chExt cx="0" cy="0"/>
+        </a:xfrm>
+      </p:grpSpPr>
       <p:sp>
         <p:nvSpPr>
           <p:cNvPr id="2" name="Rectangle 1"/>
@@ -3555,6 +3739,7 @@
           <a:lstStyle/>
           <a:p>
             <a:pPr algn="ctr"/>
+            <a:endParaRPr/>
           </a:p>
         </p:txBody>
       </p:sp>
@@ -3668,6 +3853,7 @@
           <a:lstStyle/>
           <a:p>
             <a:pPr algn="ctr"/>
+            <a:endParaRPr/>
           </a:p>
         </p:txBody>
       </p:sp>
@@ -3688,7 +3874,7 @@
           <a:noFill/>
         </p:spPr>
         <p:txBody>
-          <a:bodyPr wrap="square" lIns="0" rIns="0" tIns="0" bIns="0" anchor="t">
+          <a:bodyPr wrap="square" lIns="0" tIns="0" rIns="0" bIns="0" anchor="t">
             <a:spAutoFit/>
           </a:bodyPr>
           <a:lstStyle/>
@@ -3785,7 +3971,7 @@
 </file>
 
 <file path=ppt/slides/slide11.xml><?xml version="1.0" encoding="utf-8"?>
-<p:sld xmlns:a="http://schemas.openxmlformats.org/drawingml/2006/main" xmlns:p="http://schemas.openxmlformats.org/presentationml/2006/main" xmlns:r="http://schemas.openxmlformats.org/officeDocument/2006/relationships">
+<p:sld xmlns:a="http://schemas.openxmlformats.org/drawingml/2006/main" xmlns:r="http://schemas.openxmlformats.org/officeDocument/2006/relationships" xmlns:p="http://schemas.openxmlformats.org/presentationml/2006/main">
   <p:cSld>
     <p:bg>
       <p:bgPr>
@@ -3801,7 +3987,14 @@
         <p:cNvGrpSpPr/>
         <p:nvPr/>
       </p:nvGrpSpPr>
-      <p:grpSpPr/>
+      <p:grpSpPr>
+        <a:xfrm>
+          <a:off x="0" y="0"/>
+          <a:ext cx="0" cy="0"/>
+          <a:chOff x="0" y="0"/>
+          <a:chExt cx="0" cy="0"/>
+        </a:xfrm>
+      </p:grpSpPr>
       <p:sp>
         <p:nvSpPr>
           <p:cNvPr id="2" name="Rectangle 1"/>
@@ -3842,6 +4035,7 @@
           <a:lstStyle/>
           <a:p>
             <a:pPr algn="ctr"/>
+            <a:endParaRPr/>
           </a:p>
         </p:txBody>
       </p:sp>
@@ -3955,6 +4149,7 @@
           <a:lstStyle/>
           <a:p>
             <a:pPr algn="ctr"/>
+            <a:endParaRPr/>
           </a:p>
         </p:txBody>
       </p:sp>
@@ -3975,7 +4170,7 @@
           <a:noFill/>
         </p:spPr>
         <p:txBody>
-          <a:bodyPr wrap="square" lIns="0" rIns="0" tIns="0" bIns="0" anchor="t">
+          <a:bodyPr wrap="square" lIns="0" tIns="0" rIns="0" bIns="0" anchor="t">
             <a:spAutoFit/>
           </a:bodyPr>
           <a:lstStyle/>
@@ -4072,7 +4267,7 @@
 </file>
 
 <file path=ppt/slides/slide12.xml><?xml version="1.0" encoding="utf-8"?>
-<p:sld xmlns:a="http://schemas.openxmlformats.org/drawingml/2006/main" xmlns:p="http://schemas.openxmlformats.org/presentationml/2006/main" xmlns:r="http://schemas.openxmlformats.org/officeDocument/2006/relationships">
+<p:sld xmlns:a="http://schemas.openxmlformats.org/drawingml/2006/main" xmlns:r="http://schemas.openxmlformats.org/officeDocument/2006/relationships" xmlns:p="http://schemas.openxmlformats.org/presentationml/2006/main">
   <p:cSld>
     <p:bg>
       <p:bgPr>
@@ -4088,7 +4283,14 @@
         <p:cNvGrpSpPr/>
         <p:nvPr/>
       </p:nvGrpSpPr>
-      <p:grpSpPr/>
+      <p:grpSpPr>
+        <a:xfrm>
+          <a:off x="0" y="0"/>
+          <a:ext cx="0" cy="0"/>
+          <a:chOff x="0" y="0"/>
+          <a:chExt cx="0" cy="0"/>
+        </a:xfrm>
+      </p:grpSpPr>
       <p:sp>
         <p:nvSpPr>
           <p:cNvPr id="2" name="Rectangle 1"/>
@@ -4129,6 +4331,7 @@
           <a:lstStyle/>
           <a:p>
             <a:pPr algn="ctr"/>
+            <a:endParaRPr/>
           </a:p>
         </p:txBody>
       </p:sp>
@@ -4242,6 +4445,7 @@
           <a:lstStyle/>
           <a:p>
             <a:pPr algn="ctr"/>
+            <a:endParaRPr/>
           </a:p>
         </p:txBody>
       </p:sp>
@@ -4262,7 +4466,7 @@
           <a:noFill/>
         </p:spPr>
         <p:txBody>
-          <a:bodyPr wrap="square" lIns="0" rIns="0" tIns="0" bIns="0" anchor="t">
+          <a:bodyPr wrap="square" lIns="0" tIns="0" rIns="0" bIns="0" anchor="t">
             <a:spAutoFit/>
           </a:bodyPr>
           <a:lstStyle/>
@@ -4359,7 +4563,7 @@
 </file>
 
 <file path=ppt/slides/slide13.xml><?xml version="1.0" encoding="utf-8"?>
-<p:sld xmlns:a="http://schemas.openxmlformats.org/drawingml/2006/main" xmlns:p="http://schemas.openxmlformats.org/presentationml/2006/main" xmlns:r="http://schemas.openxmlformats.org/officeDocument/2006/relationships">
+<p:sld xmlns:a="http://schemas.openxmlformats.org/drawingml/2006/main" xmlns:r="http://schemas.openxmlformats.org/officeDocument/2006/relationships" xmlns:p="http://schemas.openxmlformats.org/presentationml/2006/main">
   <p:cSld>
     <p:bg>
       <p:bgPr>
@@ -4375,7 +4579,14 @@
         <p:cNvGrpSpPr/>
         <p:nvPr/>
       </p:nvGrpSpPr>
-      <p:grpSpPr/>
+      <p:grpSpPr>
+        <a:xfrm>
+          <a:off x="0" y="0"/>
+          <a:ext cx="0" cy="0"/>
+          <a:chOff x="0" y="0"/>
+          <a:chExt cx="0" cy="0"/>
+        </a:xfrm>
+      </p:grpSpPr>
       <p:sp>
         <p:nvSpPr>
           <p:cNvPr id="2" name="Rectangle 1"/>
@@ -4416,6 +4627,7 @@
           <a:lstStyle/>
           <a:p>
             <a:pPr algn="ctr"/>
+            <a:endParaRPr/>
           </a:p>
         </p:txBody>
       </p:sp>
@@ -4529,6 +4741,7 @@
           <a:lstStyle/>
           <a:p>
             <a:pPr algn="ctr"/>
+            <a:endParaRPr/>
           </a:p>
         </p:txBody>
       </p:sp>
@@ -4549,7 +4762,7 @@
           <a:noFill/>
         </p:spPr>
         <p:txBody>
-          <a:bodyPr wrap="square" lIns="0" rIns="0" tIns="0" bIns="0" anchor="t">
+          <a:bodyPr wrap="square" lIns="0" tIns="0" rIns="0" bIns="0" anchor="t">
             <a:spAutoFit/>
           </a:bodyPr>
           <a:lstStyle/>
@@ -4628,7 +4841,7 @@
 </file>
 
 <file path=ppt/slides/slide14.xml><?xml version="1.0" encoding="utf-8"?>
-<p:sld xmlns:a="http://schemas.openxmlformats.org/drawingml/2006/main" xmlns:p="http://schemas.openxmlformats.org/presentationml/2006/main" xmlns:r="http://schemas.openxmlformats.org/officeDocument/2006/relationships">
+<p:sld xmlns:a="http://schemas.openxmlformats.org/drawingml/2006/main" xmlns:r="http://schemas.openxmlformats.org/officeDocument/2006/relationships" xmlns:p="http://schemas.openxmlformats.org/presentationml/2006/main">
   <p:cSld>
     <p:bg>
       <p:bgPr>
@@ -4644,7 +4857,14 @@
         <p:cNvGrpSpPr/>
         <p:nvPr/>
       </p:nvGrpSpPr>
-      <p:grpSpPr/>
+      <p:grpSpPr>
+        <a:xfrm>
+          <a:off x="0" y="0"/>
+          <a:ext cx="0" cy="0"/>
+          <a:chOff x="0" y="0"/>
+          <a:chExt cx="0" cy="0"/>
+        </a:xfrm>
+      </p:grpSpPr>
       <p:sp>
         <p:nvSpPr>
           <p:cNvPr id="2" name="Rectangle 1"/>
@@ -4685,6 +4905,7 @@
           <a:lstStyle/>
           <a:p>
             <a:pPr algn="ctr"/>
+            <a:endParaRPr/>
           </a:p>
         </p:txBody>
       </p:sp>
@@ -4798,6 +5019,7 @@
           <a:lstStyle/>
           <a:p>
             <a:pPr algn="ctr"/>
+            <a:endParaRPr/>
           </a:p>
         </p:txBody>
       </p:sp>
@@ -4818,7 +5040,7 @@
           <a:noFill/>
         </p:spPr>
         <p:txBody>
-          <a:bodyPr wrap="square" lIns="0" rIns="0" tIns="0" bIns="0" anchor="t">
+          <a:bodyPr wrap="square" lIns="0" tIns="0" rIns="0" bIns="0" anchor="t">
             <a:spAutoFit/>
           </a:bodyPr>
           <a:lstStyle/>
@@ -4897,7 +5119,7 @@
 </file>
 
 <file path=ppt/slides/slide15.xml><?xml version="1.0" encoding="utf-8"?>
-<p:sld xmlns:a="http://schemas.openxmlformats.org/drawingml/2006/main" xmlns:p="http://schemas.openxmlformats.org/presentationml/2006/main" xmlns:r="http://schemas.openxmlformats.org/officeDocument/2006/relationships">
+<p:sld xmlns:a="http://schemas.openxmlformats.org/drawingml/2006/main" xmlns:r="http://schemas.openxmlformats.org/officeDocument/2006/relationships" xmlns:p="http://schemas.openxmlformats.org/presentationml/2006/main">
   <p:cSld>
     <p:bg>
       <p:bgPr>
@@ -4913,7 +5135,14 @@
         <p:cNvGrpSpPr/>
         <p:nvPr/>
       </p:nvGrpSpPr>
-      <p:grpSpPr/>
+      <p:grpSpPr>
+        <a:xfrm>
+          <a:off x="0" y="0"/>
+          <a:ext cx="0" cy="0"/>
+          <a:chOff x="0" y="0"/>
+          <a:chExt cx="0" cy="0"/>
+        </a:xfrm>
+      </p:grpSpPr>
       <p:sp>
         <p:nvSpPr>
           <p:cNvPr id="2" name="Rectangle 1"/>
@@ -4954,6 +5183,7 @@
           <a:lstStyle/>
           <a:p>
             <a:pPr algn="ctr"/>
+            <a:endParaRPr/>
           </a:p>
         </p:txBody>
       </p:sp>
@@ -5067,6 +5297,7 @@
           <a:lstStyle/>
           <a:p>
             <a:pPr algn="ctr"/>
+            <a:endParaRPr/>
           </a:p>
         </p:txBody>
       </p:sp>
@@ -5087,7 +5318,7 @@
           <a:noFill/>
         </p:spPr>
         <p:txBody>
-          <a:bodyPr wrap="square" lIns="0" rIns="0" tIns="0" bIns="0" anchor="t">
+          <a:bodyPr wrap="square" lIns="0" tIns="0" rIns="0" bIns="0" anchor="t">
             <a:spAutoFit/>
           </a:bodyPr>
           <a:lstStyle/>
@@ -5184,7 +5415,7 @@
 </file>
 
 <file path=ppt/slides/slide16.xml><?xml version="1.0" encoding="utf-8"?>
-<p:sld xmlns:a="http://schemas.openxmlformats.org/drawingml/2006/main" xmlns:p="http://schemas.openxmlformats.org/presentationml/2006/main" xmlns:r="http://schemas.openxmlformats.org/officeDocument/2006/relationships">
+<p:sld xmlns:a="http://schemas.openxmlformats.org/drawingml/2006/main" xmlns:r="http://schemas.openxmlformats.org/officeDocument/2006/relationships" xmlns:p="http://schemas.openxmlformats.org/presentationml/2006/main">
   <p:cSld>
     <p:bg>
       <p:bgPr>
@@ -5200,7 +5431,14 @@
         <p:cNvGrpSpPr/>
         <p:nvPr/>
       </p:nvGrpSpPr>
-      <p:grpSpPr/>
+      <p:grpSpPr>
+        <a:xfrm>
+          <a:off x="0" y="0"/>
+          <a:ext cx="0" cy="0"/>
+          <a:chOff x="0" y="0"/>
+          <a:chExt cx="0" cy="0"/>
+        </a:xfrm>
+      </p:grpSpPr>
       <p:sp>
         <p:nvSpPr>
           <p:cNvPr id="2" name="Rectangle 1"/>
@@ -5241,6 +5479,7 @@
           <a:lstStyle/>
           <a:p>
             <a:pPr algn="ctr"/>
+            <a:endParaRPr/>
           </a:p>
         </p:txBody>
       </p:sp>
@@ -5354,6 +5593,7 @@
           <a:lstStyle/>
           <a:p>
             <a:pPr algn="ctr"/>
+            <a:endParaRPr/>
           </a:p>
         </p:txBody>
       </p:sp>
@@ -5374,7 +5614,7 @@
           <a:noFill/>
         </p:spPr>
         <p:txBody>
-          <a:bodyPr wrap="square" lIns="0" rIns="0" tIns="0" bIns="0" anchor="t">
+          <a:bodyPr wrap="square" lIns="0" tIns="0" rIns="0" bIns="0" anchor="t">
             <a:spAutoFit/>
           </a:bodyPr>
           <a:lstStyle/>
@@ -5471,7 +5711,7 @@
 </file>
 
 <file path=ppt/slides/slide17.xml><?xml version="1.0" encoding="utf-8"?>
-<p:sld xmlns:a="http://schemas.openxmlformats.org/drawingml/2006/main" xmlns:p="http://schemas.openxmlformats.org/presentationml/2006/main" xmlns:r="http://schemas.openxmlformats.org/officeDocument/2006/relationships">
+<p:sld xmlns:a="http://schemas.openxmlformats.org/drawingml/2006/main" xmlns:r="http://schemas.openxmlformats.org/officeDocument/2006/relationships" xmlns:p="http://schemas.openxmlformats.org/presentationml/2006/main">
   <p:cSld>
     <p:bg>
       <p:bgPr>
@@ -5487,7 +5727,14 @@
         <p:cNvGrpSpPr/>
         <p:nvPr/>
       </p:nvGrpSpPr>
-      <p:grpSpPr/>
+      <p:grpSpPr>
+        <a:xfrm>
+          <a:off x="0" y="0"/>
+          <a:ext cx="0" cy="0"/>
+          <a:chOff x="0" y="0"/>
+          <a:chExt cx="0" cy="0"/>
+        </a:xfrm>
+      </p:grpSpPr>
       <p:sp>
         <p:nvSpPr>
           <p:cNvPr id="2" name="Rectangle 1"/>
@@ -5528,6 +5775,7 @@
           <a:lstStyle/>
           <a:p>
             <a:pPr algn="ctr"/>
+            <a:endParaRPr/>
           </a:p>
         </p:txBody>
       </p:sp>
@@ -5641,6 +5889,7 @@
           <a:lstStyle/>
           <a:p>
             <a:pPr algn="ctr"/>
+            <a:endParaRPr/>
           </a:p>
         </p:txBody>
       </p:sp>
@@ -5661,7 +5910,7 @@
           <a:noFill/>
         </p:spPr>
         <p:txBody>
-          <a:bodyPr wrap="square" lIns="0" rIns="0" tIns="0" bIns="0" anchor="t">
+          <a:bodyPr wrap="square" lIns="0" tIns="0" rIns="0" bIns="0" anchor="t">
             <a:spAutoFit/>
           </a:bodyPr>
           <a:lstStyle/>
@@ -5758,7 +6007,7 @@
 </file>
 
 <file path=ppt/slides/slide18.xml><?xml version="1.0" encoding="utf-8"?>
-<p:sld xmlns:a="http://schemas.openxmlformats.org/drawingml/2006/main" xmlns:p="http://schemas.openxmlformats.org/presentationml/2006/main" xmlns:r="http://schemas.openxmlformats.org/officeDocument/2006/relationships">
+<p:sld xmlns:a="http://schemas.openxmlformats.org/drawingml/2006/main" xmlns:r="http://schemas.openxmlformats.org/officeDocument/2006/relationships" xmlns:p="http://schemas.openxmlformats.org/presentationml/2006/main">
   <p:cSld>
     <p:bg>
       <p:bgPr>
@@ -5774,7 +6023,14 @@
         <p:cNvGrpSpPr/>
         <p:nvPr/>
       </p:nvGrpSpPr>
-      <p:grpSpPr/>
+      <p:grpSpPr>
+        <a:xfrm>
+          <a:off x="0" y="0"/>
+          <a:ext cx="0" cy="0"/>
+          <a:chOff x="0" y="0"/>
+          <a:chExt cx="0" cy="0"/>
+        </a:xfrm>
+      </p:grpSpPr>
       <p:sp>
         <p:nvSpPr>
           <p:cNvPr id="2" name="Rectangle 1"/>
@@ -5815,6 +6071,7 @@
           <a:lstStyle/>
           <a:p>
             <a:pPr algn="ctr"/>
+            <a:endParaRPr/>
           </a:p>
         </p:txBody>
       </p:sp>
@@ -5928,6 +6185,7 @@
           <a:lstStyle/>
           <a:p>
             <a:pPr algn="ctr"/>
+            <a:endParaRPr/>
           </a:p>
         </p:txBody>
       </p:sp>
@@ -5948,7 +6206,7 @@
           <a:noFill/>
         </p:spPr>
         <p:txBody>
-          <a:bodyPr wrap="square" lIns="0" rIns="0" tIns="0" bIns="0" anchor="t">
+          <a:bodyPr wrap="square" lIns="0" tIns="0" rIns="0" bIns="0" anchor="t">
             <a:spAutoFit/>
           </a:bodyPr>
           <a:lstStyle/>
@@ -6045,7 +6303,7 @@
 </file>
 
 <file path=ppt/slides/slide19.xml><?xml version="1.0" encoding="utf-8"?>
-<p:sld xmlns:a="http://schemas.openxmlformats.org/drawingml/2006/main" xmlns:p="http://schemas.openxmlformats.org/presentationml/2006/main" xmlns:r="http://schemas.openxmlformats.org/officeDocument/2006/relationships">
+<p:sld xmlns:a="http://schemas.openxmlformats.org/drawingml/2006/main" xmlns:r="http://schemas.openxmlformats.org/officeDocument/2006/relationships" xmlns:p="http://schemas.openxmlformats.org/presentationml/2006/main">
   <p:cSld>
     <p:bg>
       <p:bgPr>
@@ -6061,7 +6319,14 @@
         <p:cNvGrpSpPr/>
         <p:nvPr/>
       </p:nvGrpSpPr>
-      <p:grpSpPr/>
+      <p:grpSpPr>
+        <a:xfrm>
+          <a:off x="0" y="0"/>
+          <a:ext cx="0" cy="0"/>
+          <a:chOff x="0" y="0"/>
+          <a:chExt cx="0" cy="0"/>
+        </a:xfrm>
+      </p:grpSpPr>
       <p:sp>
         <p:nvSpPr>
           <p:cNvPr id="2" name="Rectangle 1"/>
@@ -6102,6 +6367,7 @@
           <a:lstStyle/>
           <a:p>
             <a:pPr algn="ctr"/>
+            <a:endParaRPr/>
           </a:p>
         </p:txBody>
       </p:sp>
@@ -6215,6 +6481,7 @@
           <a:lstStyle/>
           <a:p>
             <a:pPr algn="ctr"/>
+            <a:endParaRPr/>
           </a:p>
         </p:txBody>
       </p:sp>
@@ -6235,7 +6502,7 @@
           <a:noFill/>
         </p:spPr>
         <p:txBody>
-          <a:bodyPr wrap="square" lIns="0" rIns="0" tIns="0" bIns="0" anchor="t">
+          <a:bodyPr wrap="square" lIns="0" tIns="0" rIns="0" bIns="0" anchor="t">
             <a:spAutoFit/>
           </a:bodyPr>
           <a:lstStyle/>
@@ -6298,7 +6565,7 @@
 </file>
 
 <file path=ppt/slides/slide2.xml><?xml version="1.0" encoding="utf-8"?>
-<p:sld xmlns:a="http://schemas.openxmlformats.org/drawingml/2006/main" xmlns:p="http://schemas.openxmlformats.org/presentationml/2006/main" xmlns:r="http://schemas.openxmlformats.org/officeDocument/2006/relationships">
+<p:sld xmlns:a="http://schemas.openxmlformats.org/drawingml/2006/main" xmlns:r="http://schemas.openxmlformats.org/officeDocument/2006/relationships" xmlns:p="http://schemas.openxmlformats.org/presentationml/2006/main">
   <p:cSld>
     <p:bg>
       <p:bgPr>
@@ -6314,7 +6581,14 @@
         <p:cNvGrpSpPr/>
         <p:nvPr/>
       </p:nvGrpSpPr>
-      <p:grpSpPr/>
+      <p:grpSpPr>
+        <a:xfrm>
+          <a:off x="0" y="0"/>
+          <a:ext cx="0" cy="0"/>
+          <a:chOff x="0" y="0"/>
+          <a:chExt cx="0" cy="0"/>
+        </a:xfrm>
+      </p:grpSpPr>
       <p:sp>
         <p:nvSpPr>
           <p:cNvPr id="2" name="Rectangle 1"/>
@@ -6355,6 +6629,7 @@
           <a:lstStyle/>
           <a:p>
             <a:pPr algn="ctr"/>
+            <a:endParaRPr/>
           </a:p>
         </p:txBody>
       </p:sp>
@@ -6468,6 +6743,7 @@
           <a:lstStyle/>
           <a:p>
             <a:pPr algn="ctr"/>
+            <a:endParaRPr/>
           </a:p>
         </p:txBody>
       </p:sp>
@@ -6488,7 +6764,7 @@
           <a:noFill/>
         </p:spPr>
         <p:txBody>
-          <a:bodyPr wrap="square" lIns="0" rIns="0" tIns="0" bIns="0" anchor="t">
+          <a:bodyPr wrap="square" lIns="0" tIns="0" rIns="0" bIns="0" anchor="t">
             <a:spAutoFit/>
           </a:bodyPr>
           <a:lstStyle/>
@@ -6585,7 +6861,7 @@
 </file>
 
 <file path=ppt/slides/slide20.xml><?xml version="1.0" encoding="utf-8"?>
-<p:sld xmlns:a="http://schemas.openxmlformats.org/drawingml/2006/main" xmlns:p="http://schemas.openxmlformats.org/presentationml/2006/main" xmlns:r="http://schemas.openxmlformats.org/officeDocument/2006/relationships">
+<p:sld xmlns:a="http://schemas.openxmlformats.org/drawingml/2006/main" xmlns:r="http://schemas.openxmlformats.org/officeDocument/2006/relationships" xmlns:p="http://schemas.openxmlformats.org/presentationml/2006/main">
   <p:cSld>
     <p:bg>
       <p:bgPr>
@@ -6601,7 +6877,14 @@
         <p:cNvGrpSpPr/>
         <p:nvPr/>
       </p:nvGrpSpPr>
-      <p:grpSpPr/>
+      <p:grpSpPr>
+        <a:xfrm>
+          <a:off x="0" y="0"/>
+          <a:ext cx="0" cy="0"/>
+          <a:chOff x="0" y="0"/>
+          <a:chExt cx="0" cy="0"/>
+        </a:xfrm>
+      </p:grpSpPr>
       <p:sp>
         <p:nvSpPr>
           <p:cNvPr id="2" name="Rectangle 1"/>
@@ -6642,6 +6925,7 @@
           <a:lstStyle/>
           <a:p>
             <a:pPr algn="ctr"/>
+            <a:endParaRPr/>
           </a:p>
         </p:txBody>
       </p:sp>
@@ -6755,6 +7039,7 @@
           <a:lstStyle/>
           <a:p>
             <a:pPr algn="ctr"/>
+            <a:endParaRPr/>
           </a:p>
         </p:txBody>
       </p:sp>
@@ -6936,6 +7221,7 @@
           <a:lstStyle/>
           <a:p>
             <a:pPr algn="ctr"/>
+            <a:endParaRPr/>
           </a:p>
         </p:txBody>
       </p:sp>
@@ -7117,6 +7403,7 @@
           <a:lstStyle/>
           <a:p>
             <a:pPr algn="ctr"/>
+            <a:endParaRPr/>
           </a:p>
         </p:txBody>
       </p:sp>
@@ -7298,6 +7585,7 @@
           <a:lstStyle/>
           <a:p>
             <a:pPr algn="ctr"/>
+            <a:endParaRPr/>
           </a:p>
         </p:txBody>
       </p:sp>
@@ -7479,6 +7767,7 @@
           <a:lstStyle/>
           <a:p>
             <a:pPr algn="ctr"/>
+            <a:endParaRPr/>
           </a:p>
         </p:txBody>
       </p:sp>
@@ -7660,6 +7949,7 @@
           <a:lstStyle/>
           <a:p>
             <a:pPr algn="ctr"/>
+            <a:endParaRPr/>
           </a:p>
         </p:txBody>
       </p:sp>
@@ -7842,7 +8132,7 @@
 </file>
 
 <file path=ppt/slides/slide21.xml><?xml version="1.0" encoding="utf-8"?>
-<p:sld xmlns:a="http://schemas.openxmlformats.org/drawingml/2006/main" xmlns:p="http://schemas.openxmlformats.org/presentationml/2006/main" xmlns:r="http://schemas.openxmlformats.org/officeDocument/2006/relationships">
+<p:sld xmlns:a="http://schemas.openxmlformats.org/drawingml/2006/main" xmlns:r="http://schemas.openxmlformats.org/officeDocument/2006/relationships" xmlns:p="http://schemas.openxmlformats.org/presentationml/2006/main">
   <p:cSld>
     <p:bg>
       <p:bgPr>
@@ -7858,7 +8148,14 @@
         <p:cNvGrpSpPr/>
         <p:nvPr/>
       </p:nvGrpSpPr>
-      <p:grpSpPr/>
+      <p:grpSpPr>
+        <a:xfrm>
+          <a:off x="0" y="0"/>
+          <a:ext cx="0" cy="0"/>
+          <a:chOff x="0" y="0"/>
+          <a:chExt cx="0" cy="0"/>
+        </a:xfrm>
+      </p:grpSpPr>
       <p:sp>
         <p:nvSpPr>
           <p:cNvPr id="2" name="Rectangle 1"/>
@@ -7899,6 +8196,7 @@
           <a:lstStyle/>
           <a:p>
             <a:pPr algn="ctr"/>
+            <a:endParaRPr/>
           </a:p>
         </p:txBody>
       </p:sp>
@@ -8012,6 +8310,7 @@
           <a:lstStyle/>
           <a:p>
             <a:pPr algn="ctr"/>
+            <a:endParaRPr/>
           </a:p>
         </p:txBody>
       </p:sp>
@@ -8091,6 +8390,7 @@
           <a:lstStyle/>
           <a:p>
             <a:pPr algn="ctr"/>
+            <a:endParaRPr/>
           </a:p>
         </p:txBody>
       </p:sp>
@@ -8275,6 +8575,7 @@
           <a:lstStyle/>
           <a:p>
             <a:pPr algn="ctr"/>
+            <a:endParaRPr/>
           </a:p>
         </p:txBody>
       </p:sp>
@@ -8460,7 +8761,7 @@
 </file>
 
 <file path=ppt/slides/slide22.xml><?xml version="1.0" encoding="utf-8"?>
-<p:sld xmlns:a="http://schemas.openxmlformats.org/drawingml/2006/main" xmlns:p="http://schemas.openxmlformats.org/presentationml/2006/main" xmlns:r="http://schemas.openxmlformats.org/officeDocument/2006/relationships">
+<p:sld xmlns:a="http://schemas.openxmlformats.org/drawingml/2006/main" xmlns:r="http://schemas.openxmlformats.org/officeDocument/2006/relationships" xmlns:p="http://schemas.openxmlformats.org/presentationml/2006/main">
   <p:cSld>
     <p:bg>
       <p:bgPr>
@@ -8476,7 +8777,14 @@
         <p:cNvGrpSpPr/>
         <p:nvPr/>
       </p:nvGrpSpPr>
-      <p:grpSpPr/>
+      <p:grpSpPr>
+        <a:xfrm>
+          <a:off x="0" y="0"/>
+          <a:ext cx="0" cy="0"/>
+          <a:chOff x="0" y="0"/>
+          <a:chExt cx="0" cy="0"/>
+        </a:xfrm>
+      </p:grpSpPr>
       <p:sp>
         <p:nvSpPr>
           <p:cNvPr id="2" name="Rectangle 1"/>
@@ -8517,6 +8825,7 @@
           <a:lstStyle/>
           <a:p>
             <a:pPr algn="ctr"/>
+            <a:endParaRPr/>
           </a:p>
         </p:txBody>
       </p:sp>
@@ -8630,6 +8939,7 @@
           <a:lstStyle/>
           <a:p>
             <a:pPr algn="ctr"/>
+            <a:endParaRPr/>
           </a:p>
         </p:txBody>
       </p:sp>
@@ -8650,7 +8960,7 @@
           <a:noFill/>
         </p:spPr>
         <p:txBody>
-          <a:bodyPr wrap="square" lIns="0" rIns="0" tIns="0" bIns="0" anchor="t">
+          <a:bodyPr wrap="square" lIns="0" tIns="0" rIns="0" bIns="0" anchor="t">
             <a:spAutoFit/>
           </a:bodyPr>
           <a:lstStyle/>
@@ -8713,7 +9023,7 @@
 </file>
 
 <file path=ppt/slides/slide23.xml><?xml version="1.0" encoding="utf-8"?>
-<p:sld xmlns:a="http://schemas.openxmlformats.org/drawingml/2006/main" xmlns:p="http://schemas.openxmlformats.org/presentationml/2006/main" xmlns:r="http://schemas.openxmlformats.org/officeDocument/2006/relationships">
+<p:sld xmlns:a="http://schemas.openxmlformats.org/drawingml/2006/main" xmlns:r="http://schemas.openxmlformats.org/officeDocument/2006/relationships" xmlns:p="http://schemas.openxmlformats.org/presentationml/2006/main">
   <p:cSld>
     <p:bg>
       <p:bgPr>
@@ -8729,7 +9039,14 @@
         <p:cNvGrpSpPr/>
         <p:nvPr/>
       </p:nvGrpSpPr>
-      <p:grpSpPr/>
+      <p:grpSpPr>
+        <a:xfrm>
+          <a:off x="0" y="0"/>
+          <a:ext cx="0" cy="0"/>
+          <a:chOff x="0" y="0"/>
+          <a:chExt cx="0" cy="0"/>
+        </a:xfrm>
+      </p:grpSpPr>
       <p:sp>
         <p:nvSpPr>
           <p:cNvPr id="2" name="Rectangle 1"/>
@@ -8770,6 +9087,7 @@
           <a:lstStyle/>
           <a:p>
             <a:pPr algn="ctr"/>
+            <a:endParaRPr/>
           </a:p>
         </p:txBody>
       </p:sp>
@@ -8883,6 +9201,7 @@
           <a:lstStyle/>
           <a:p>
             <a:pPr algn="ctr"/>
+            <a:endParaRPr/>
           </a:p>
         </p:txBody>
       </p:sp>
@@ -8903,7 +9222,7 @@
           <a:noFill/>
         </p:spPr>
         <p:txBody>
-          <a:bodyPr wrap="square" lIns="0" rIns="0" tIns="0" bIns="0" anchor="t">
+          <a:bodyPr wrap="square" lIns="0" tIns="0" rIns="0" bIns="0" anchor="t">
             <a:spAutoFit/>
           </a:bodyPr>
           <a:lstStyle/>
@@ -8982,7 +9301,7 @@
 </file>
 
 <file path=ppt/slides/slide24.xml><?xml version="1.0" encoding="utf-8"?>
-<p:sld xmlns:a="http://schemas.openxmlformats.org/drawingml/2006/main" xmlns:p="http://schemas.openxmlformats.org/presentationml/2006/main" xmlns:r="http://schemas.openxmlformats.org/officeDocument/2006/relationships">
+<p:sld xmlns:a="http://schemas.openxmlformats.org/drawingml/2006/main" xmlns:r="http://schemas.openxmlformats.org/officeDocument/2006/relationships" xmlns:p="http://schemas.openxmlformats.org/presentationml/2006/main">
   <p:cSld>
     <p:bg>
       <p:bgPr>
@@ -8998,7 +9317,14 @@
         <p:cNvGrpSpPr/>
         <p:nvPr/>
       </p:nvGrpSpPr>
-      <p:grpSpPr/>
+      <p:grpSpPr>
+        <a:xfrm>
+          <a:off x="0" y="0"/>
+          <a:ext cx="0" cy="0"/>
+          <a:chOff x="0" y="0"/>
+          <a:chExt cx="0" cy="0"/>
+        </a:xfrm>
+      </p:grpSpPr>
       <p:sp>
         <p:nvSpPr>
           <p:cNvPr id="2" name="Rectangle 1"/>
@@ -9039,6 +9365,7 @@
           <a:lstStyle/>
           <a:p>
             <a:pPr algn="ctr"/>
+            <a:endParaRPr/>
           </a:p>
         </p:txBody>
       </p:sp>
@@ -9152,6 +9479,7 @@
           <a:lstStyle/>
           <a:p>
             <a:pPr algn="ctr"/>
+            <a:endParaRPr/>
           </a:p>
         </p:txBody>
       </p:sp>
@@ -9172,7 +9500,7 @@
           <a:noFill/>
         </p:spPr>
         <p:txBody>
-          <a:bodyPr wrap="square" lIns="0" rIns="0" tIns="0" bIns="0" anchor="t">
+          <a:bodyPr wrap="square" lIns="0" tIns="0" rIns="0" bIns="0" anchor="t">
             <a:spAutoFit/>
           </a:bodyPr>
           <a:lstStyle/>
@@ -9251,7 +9579,7 @@
 </file>
 
 <file path=ppt/slides/slide25.xml><?xml version="1.0" encoding="utf-8"?>
-<p:sld xmlns:a="http://schemas.openxmlformats.org/drawingml/2006/main" xmlns:p="http://schemas.openxmlformats.org/presentationml/2006/main" xmlns:r="http://schemas.openxmlformats.org/officeDocument/2006/relationships">
+<p:sld xmlns:a="http://schemas.openxmlformats.org/drawingml/2006/main" xmlns:r="http://schemas.openxmlformats.org/officeDocument/2006/relationships" xmlns:p="http://schemas.openxmlformats.org/presentationml/2006/main">
   <p:cSld>
     <p:bg>
       <p:bgPr>
@@ -9267,7 +9595,14 @@
         <p:cNvGrpSpPr/>
         <p:nvPr/>
       </p:nvGrpSpPr>
-      <p:grpSpPr/>
+      <p:grpSpPr>
+        <a:xfrm>
+          <a:off x="0" y="0"/>
+          <a:ext cx="0" cy="0"/>
+          <a:chOff x="0" y="0"/>
+          <a:chExt cx="0" cy="0"/>
+        </a:xfrm>
+      </p:grpSpPr>
       <p:sp>
         <p:nvSpPr>
           <p:cNvPr id="2" name="Rectangle 1"/>
@@ -9308,6 +9643,7 @@
           <a:lstStyle/>
           <a:p>
             <a:pPr algn="ctr"/>
+            <a:endParaRPr/>
           </a:p>
         </p:txBody>
       </p:sp>
@@ -9421,6 +9757,7 @@
           <a:lstStyle/>
           <a:p>
             <a:pPr algn="ctr"/>
+            <a:endParaRPr/>
           </a:p>
         </p:txBody>
       </p:sp>
@@ -9441,7 +9778,7 @@
           <a:noFill/>
         </p:spPr>
         <p:txBody>
-          <a:bodyPr wrap="square" lIns="0" rIns="0" tIns="0" bIns="0" anchor="t">
+          <a:bodyPr wrap="square" lIns="0" tIns="0" rIns="0" bIns="0" anchor="t">
             <a:spAutoFit/>
           </a:bodyPr>
           <a:lstStyle/>
@@ -9520,7 +9857,7 @@
 </file>
 
 <file path=ppt/slides/slide26.xml><?xml version="1.0" encoding="utf-8"?>
-<p:sld xmlns:a="http://schemas.openxmlformats.org/drawingml/2006/main" xmlns:p="http://schemas.openxmlformats.org/presentationml/2006/main" xmlns:r="http://schemas.openxmlformats.org/officeDocument/2006/relationships">
+<p:sld xmlns:a="http://schemas.openxmlformats.org/drawingml/2006/main" xmlns:r="http://schemas.openxmlformats.org/officeDocument/2006/relationships" xmlns:p="http://schemas.openxmlformats.org/presentationml/2006/main">
   <p:cSld>
     <p:bg>
       <p:bgPr>
@@ -9536,7 +9873,14 @@
         <p:cNvGrpSpPr/>
         <p:nvPr/>
       </p:nvGrpSpPr>
-      <p:grpSpPr/>
+      <p:grpSpPr>
+        <a:xfrm>
+          <a:off x="0" y="0"/>
+          <a:ext cx="0" cy="0"/>
+          <a:chOff x="0" y="0"/>
+          <a:chExt cx="0" cy="0"/>
+        </a:xfrm>
+      </p:grpSpPr>
       <p:sp>
         <p:nvSpPr>
           <p:cNvPr id="2" name="Rectangle 1"/>
@@ -9577,6 +9921,7 @@
           <a:lstStyle/>
           <a:p>
             <a:pPr algn="ctr"/>
+            <a:endParaRPr/>
           </a:p>
         </p:txBody>
       </p:sp>
@@ -9690,6 +10035,7 @@
           <a:lstStyle/>
           <a:p>
             <a:pPr algn="ctr"/>
+            <a:endParaRPr/>
           </a:p>
         </p:txBody>
       </p:sp>
@@ -9710,7 +10056,7 @@
           <a:noFill/>
         </p:spPr>
         <p:txBody>
-          <a:bodyPr wrap="square" lIns="0" rIns="0" tIns="0" bIns="0" anchor="t">
+          <a:bodyPr wrap="square" lIns="0" tIns="0" rIns="0" bIns="0" anchor="t">
             <a:spAutoFit/>
           </a:bodyPr>
           <a:lstStyle/>
@@ -9773,7 +10119,7 @@
 </file>
 
 <file path=ppt/slides/slide27.xml><?xml version="1.0" encoding="utf-8"?>
-<p:sld xmlns:a="http://schemas.openxmlformats.org/drawingml/2006/main" xmlns:p="http://schemas.openxmlformats.org/presentationml/2006/main" xmlns:r="http://schemas.openxmlformats.org/officeDocument/2006/relationships">
+<p:sld xmlns:a="http://schemas.openxmlformats.org/drawingml/2006/main" xmlns:r="http://schemas.openxmlformats.org/officeDocument/2006/relationships" xmlns:p="http://schemas.openxmlformats.org/presentationml/2006/main">
   <p:cSld>
     <p:bg>
       <p:bgPr>
@@ -9789,7 +10135,14 @@
         <p:cNvGrpSpPr/>
         <p:nvPr/>
       </p:nvGrpSpPr>
-      <p:grpSpPr/>
+      <p:grpSpPr>
+        <a:xfrm>
+          <a:off x="0" y="0"/>
+          <a:ext cx="0" cy="0"/>
+          <a:chOff x="0" y="0"/>
+          <a:chExt cx="0" cy="0"/>
+        </a:xfrm>
+      </p:grpSpPr>
       <p:sp>
         <p:nvSpPr>
           <p:cNvPr id="2" name="Rectangle 1"/>
@@ -9830,6 +10183,7 @@
           <a:lstStyle/>
           <a:p>
             <a:pPr algn="ctr"/>
+            <a:endParaRPr/>
           </a:p>
         </p:txBody>
       </p:sp>
@@ -9943,6 +10297,7 @@
           <a:lstStyle/>
           <a:p>
             <a:pPr algn="ctr"/>
+            <a:endParaRPr/>
           </a:p>
         </p:txBody>
       </p:sp>
@@ -9963,7 +10318,7 @@
           <a:noFill/>
         </p:spPr>
         <p:txBody>
-          <a:bodyPr wrap="square" lIns="0" rIns="0" tIns="0" bIns="0" anchor="t">
+          <a:bodyPr wrap="square" lIns="0" tIns="0" rIns="0" bIns="0" anchor="t">
             <a:spAutoFit/>
           </a:bodyPr>
           <a:lstStyle/>
@@ -10026,7 +10381,7 @@
 </file>
 
 <file path=ppt/slides/slide28.xml><?xml version="1.0" encoding="utf-8"?>
-<p:sld xmlns:a="http://schemas.openxmlformats.org/drawingml/2006/main" xmlns:p="http://schemas.openxmlformats.org/presentationml/2006/main" xmlns:r="http://schemas.openxmlformats.org/officeDocument/2006/relationships">
+<p:sld xmlns:a="http://schemas.openxmlformats.org/drawingml/2006/main" xmlns:r="http://schemas.openxmlformats.org/officeDocument/2006/relationships" xmlns:p="http://schemas.openxmlformats.org/presentationml/2006/main">
   <p:cSld>
     <p:bg>
       <p:bgPr>
@@ -10042,7 +10397,14 @@
         <p:cNvGrpSpPr/>
         <p:nvPr/>
       </p:nvGrpSpPr>
-      <p:grpSpPr/>
+      <p:grpSpPr>
+        <a:xfrm>
+          <a:off x="0" y="0"/>
+          <a:ext cx="0" cy="0"/>
+          <a:chOff x="0" y="0"/>
+          <a:chExt cx="0" cy="0"/>
+        </a:xfrm>
+      </p:grpSpPr>
       <p:sp>
         <p:nvSpPr>
           <p:cNvPr id="2" name="Rectangle 1"/>
@@ -10083,6 +10445,7 @@
           <a:lstStyle/>
           <a:p>
             <a:pPr algn="ctr"/>
+            <a:endParaRPr/>
           </a:p>
         </p:txBody>
       </p:sp>
@@ -10128,6 +10491,7 @@
           <a:lstStyle/>
           <a:p>
             <a:pPr algn="ctr"/>
+            <a:endParaRPr/>
           </a:p>
         </p:txBody>
       </p:sp>
@@ -10171,6 +10535,7 @@
           <a:lstStyle/>
           <a:p>
             <a:pPr algn="ctr"/>
+            <a:endParaRPr/>
           </a:p>
         </p:txBody>
       </p:sp>
@@ -10251,7 +10616,7 @@
 </file>
 
 <file path=ppt/slides/slide29.xml><?xml version="1.0" encoding="utf-8"?>
-<p:sld xmlns:a="http://schemas.openxmlformats.org/drawingml/2006/main" xmlns:p="http://schemas.openxmlformats.org/presentationml/2006/main" xmlns:r="http://schemas.openxmlformats.org/officeDocument/2006/relationships">
+<p:sld xmlns:a="http://schemas.openxmlformats.org/drawingml/2006/main" xmlns:r="http://schemas.openxmlformats.org/officeDocument/2006/relationships" xmlns:p="http://schemas.openxmlformats.org/presentationml/2006/main">
   <p:cSld>
     <p:bg>
       <p:bgPr>
@@ -10267,7 +10632,14 @@
         <p:cNvGrpSpPr/>
         <p:nvPr/>
       </p:nvGrpSpPr>
-      <p:grpSpPr/>
+      <p:grpSpPr>
+        <a:xfrm>
+          <a:off x="0" y="0"/>
+          <a:ext cx="0" cy="0"/>
+          <a:chOff x="0" y="0"/>
+          <a:chExt cx="0" cy="0"/>
+        </a:xfrm>
+      </p:grpSpPr>
       <p:sp>
         <p:nvSpPr>
           <p:cNvPr id="2" name="Rectangle 1"/>
@@ -10308,6 +10680,7 @@
           <a:lstStyle/>
           <a:p>
             <a:pPr algn="ctr"/>
+            <a:endParaRPr/>
           </a:p>
         </p:txBody>
       </p:sp>
@@ -10421,6 +10794,7 @@
           <a:lstStyle/>
           <a:p>
             <a:pPr algn="ctr"/>
+            <a:endParaRPr/>
           </a:p>
         </p:txBody>
       </p:sp>
@@ -10441,7 +10815,7 @@
           <a:noFill/>
         </p:spPr>
         <p:txBody>
-          <a:bodyPr wrap="square" lIns="0" rIns="0" tIns="0" bIns="0" anchor="t">
+          <a:bodyPr wrap="square" lIns="0" tIns="0" rIns="0" bIns="0" anchor="t">
             <a:spAutoFit/>
           </a:bodyPr>
           <a:lstStyle/>
@@ -10504,7 +10878,7 @@
 </file>
 
 <file path=ppt/slides/slide3.xml><?xml version="1.0" encoding="utf-8"?>
-<p:sld xmlns:a="http://schemas.openxmlformats.org/drawingml/2006/main" xmlns:p="http://schemas.openxmlformats.org/presentationml/2006/main" xmlns:r="http://schemas.openxmlformats.org/officeDocument/2006/relationships">
+<p:sld xmlns:a="http://schemas.openxmlformats.org/drawingml/2006/main" xmlns:r="http://schemas.openxmlformats.org/officeDocument/2006/relationships" xmlns:p="http://schemas.openxmlformats.org/presentationml/2006/main">
   <p:cSld>
     <p:bg>
       <p:bgPr>
@@ -10520,7 +10894,14 @@
         <p:cNvGrpSpPr/>
         <p:nvPr/>
       </p:nvGrpSpPr>
-      <p:grpSpPr/>
+      <p:grpSpPr>
+        <a:xfrm>
+          <a:off x="0" y="0"/>
+          <a:ext cx="0" cy="0"/>
+          <a:chOff x="0" y="0"/>
+          <a:chExt cx="0" cy="0"/>
+        </a:xfrm>
+      </p:grpSpPr>
       <p:sp>
         <p:nvSpPr>
           <p:cNvPr id="2" name="Rectangle 1"/>
@@ -10561,6 +10942,7 @@
           <a:lstStyle/>
           <a:p>
             <a:pPr algn="ctr"/>
+            <a:endParaRPr/>
           </a:p>
         </p:txBody>
       </p:sp>
@@ -10674,6 +11056,7 @@
           <a:lstStyle/>
           <a:p>
             <a:pPr algn="ctr"/>
+            <a:endParaRPr/>
           </a:p>
         </p:txBody>
       </p:sp>
@@ -10694,7 +11077,7 @@
           <a:noFill/>
         </p:spPr>
         <p:txBody>
-          <a:bodyPr wrap="square" lIns="0" rIns="0" tIns="0" bIns="0" anchor="t">
+          <a:bodyPr wrap="square" lIns="0" tIns="0" rIns="0" bIns="0" anchor="t">
             <a:spAutoFit/>
           </a:bodyPr>
           <a:lstStyle/>
@@ -10773,7 +11156,7 @@
 </file>
 
 <file path=ppt/slides/slide30.xml><?xml version="1.0" encoding="utf-8"?>
-<p:sld xmlns:a="http://schemas.openxmlformats.org/drawingml/2006/main" xmlns:p="http://schemas.openxmlformats.org/presentationml/2006/main" xmlns:r="http://schemas.openxmlformats.org/officeDocument/2006/relationships">
+<p:sld xmlns:a="http://schemas.openxmlformats.org/drawingml/2006/main" xmlns:r="http://schemas.openxmlformats.org/officeDocument/2006/relationships" xmlns:p="http://schemas.openxmlformats.org/presentationml/2006/main">
   <p:cSld>
     <p:bg>
       <p:bgPr>
@@ -10789,7 +11172,14 @@
         <p:cNvGrpSpPr/>
         <p:nvPr/>
       </p:nvGrpSpPr>
-      <p:grpSpPr/>
+      <p:grpSpPr>
+        <a:xfrm>
+          <a:off x="0" y="0"/>
+          <a:ext cx="0" cy="0"/>
+          <a:chOff x="0" y="0"/>
+          <a:chExt cx="0" cy="0"/>
+        </a:xfrm>
+      </p:grpSpPr>
       <p:sp>
         <p:nvSpPr>
           <p:cNvPr id="2" name="Rectangle 1"/>
@@ -10830,6 +11220,7 @@
           <a:lstStyle/>
           <a:p>
             <a:pPr algn="ctr"/>
+            <a:endParaRPr/>
           </a:p>
         </p:txBody>
       </p:sp>
@@ -10943,6 +11334,7 @@
           <a:lstStyle/>
           <a:p>
             <a:pPr algn="ctr"/>
+            <a:endParaRPr/>
           </a:p>
         </p:txBody>
       </p:sp>
@@ -10963,7 +11355,7 @@
           <a:noFill/>
         </p:spPr>
         <p:txBody>
-          <a:bodyPr wrap="square" lIns="0" rIns="0" tIns="0" bIns="0" anchor="t">
+          <a:bodyPr wrap="square" lIns="0" tIns="0" rIns="0" bIns="0" anchor="t">
             <a:spAutoFit/>
           </a:bodyPr>
           <a:lstStyle/>
@@ -11060,7 +11452,7 @@
 </file>
 
 <file path=ppt/slides/slide31.xml><?xml version="1.0" encoding="utf-8"?>
-<p:sld xmlns:a="http://schemas.openxmlformats.org/drawingml/2006/main" xmlns:p="http://schemas.openxmlformats.org/presentationml/2006/main" xmlns:r="http://schemas.openxmlformats.org/officeDocument/2006/relationships">
+<p:sld xmlns:a="http://schemas.openxmlformats.org/drawingml/2006/main" xmlns:r="http://schemas.openxmlformats.org/officeDocument/2006/relationships" xmlns:p="http://schemas.openxmlformats.org/presentationml/2006/main">
   <p:cSld>
     <p:bg>
       <p:bgPr>
@@ -11076,7 +11468,14 @@
         <p:cNvGrpSpPr/>
         <p:nvPr/>
       </p:nvGrpSpPr>
-      <p:grpSpPr/>
+      <p:grpSpPr>
+        <a:xfrm>
+          <a:off x="0" y="0"/>
+          <a:ext cx="0" cy="0"/>
+          <a:chOff x="0" y="0"/>
+          <a:chExt cx="0" cy="0"/>
+        </a:xfrm>
+      </p:grpSpPr>
       <p:sp>
         <p:nvSpPr>
           <p:cNvPr id="2" name="Rectangle 1"/>
@@ -11117,6 +11516,7 @@
           <a:lstStyle/>
           <a:p>
             <a:pPr algn="ctr"/>
+            <a:endParaRPr/>
           </a:p>
         </p:txBody>
       </p:sp>
@@ -11230,6 +11630,7 @@
           <a:lstStyle/>
           <a:p>
             <a:pPr algn="ctr"/>
+            <a:endParaRPr/>
           </a:p>
         </p:txBody>
       </p:sp>
@@ -11250,7 +11651,7 @@
           <a:noFill/>
         </p:spPr>
         <p:txBody>
-          <a:bodyPr wrap="square" lIns="0" rIns="0" tIns="0" bIns="0" anchor="t">
+          <a:bodyPr wrap="square" lIns="0" tIns="0" rIns="0" bIns="0" anchor="t">
             <a:spAutoFit/>
           </a:bodyPr>
           <a:lstStyle/>
@@ -11347,7 +11748,7 @@
 </file>
 
 <file path=ppt/slides/slide32.xml><?xml version="1.0" encoding="utf-8"?>
-<p:sld xmlns:a="http://schemas.openxmlformats.org/drawingml/2006/main" xmlns:p="http://schemas.openxmlformats.org/presentationml/2006/main" xmlns:r="http://schemas.openxmlformats.org/officeDocument/2006/relationships">
+<p:sld xmlns:a="http://schemas.openxmlformats.org/drawingml/2006/main" xmlns:r="http://schemas.openxmlformats.org/officeDocument/2006/relationships" xmlns:p="http://schemas.openxmlformats.org/presentationml/2006/main">
   <p:cSld>
     <p:bg>
       <p:bgPr>
@@ -11363,7 +11764,14 @@
         <p:cNvGrpSpPr/>
         <p:nvPr/>
       </p:nvGrpSpPr>
-      <p:grpSpPr/>
+      <p:grpSpPr>
+        <a:xfrm>
+          <a:off x="0" y="0"/>
+          <a:ext cx="0" cy="0"/>
+          <a:chOff x="0" y="0"/>
+          <a:chExt cx="0" cy="0"/>
+        </a:xfrm>
+      </p:grpSpPr>
       <p:sp>
         <p:nvSpPr>
           <p:cNvPr id="2" name="Rectangle 1"/>
@@ -11404,6 +11812,7 @@
           <a:lstStyle/>
           <a:p>
             <a:pPr algn="ctr"/>
+            <a:endParaRPr/>
           </a:p>
         </p:txBody>
       </p:sp>
@@ -11517,6 +11926,7 @@
           <a:lstStyle/>
           <a:p>
             <a:pPr algn="ctr"/>
+            <a:endParaRPr/>
           </a:p>
         </p:txBody>
       </p:sp>
@@ -11537,7 +11947,7 @@
           <a:noFill/>
         </p:spPr>
         <p:txBody>
-          <a:bodyPr wrap="square" lIns="0" rIns="0" tIns="0" bIns="0" anchor="t">
+          <a:bodyPr wrap="square" lIns="0" tIns="0" rIns="0" bIns="0" anchor="t">
             <a:spAutoFit/>
           </a:bodyPr>
           <a:lstStyle/>
@@ -11634,7 +12044,7 @@
 </file>
 
 <file path=ppt/slides/slide33.xml><?xml version="1.0" encoding="utf-8"?>
-<p:sld xmlns:a="http://schemas.openxmlformats.org/drawingml/2006/main" xmlns:p="http://schemas.openxmlformats.org/presentationml/2006/main" xmlns:r="http://schemas.openxmlformats.org/officeDocument/2006/relationships">
+<p:sld xmlns:a="http://schemas.openxmlformats.org/drawingml/2006/main" xmlns:r="http://schemas.openxmlformats.org/officeDocument/2006/relationships" xmlns:p="http://schemas.openxmlformats.org/presentationml/2006/main">
   <p:cSld>
     <p:bg>
       <p:bgPr>
@@ -11650,7 +12060,14 @@
         <p:cNvGrpSpPr/>
         <p:nvPr/>
       </p:nvGrpSpPr>
-      <p:grpSpPr/>
+      <p:grpSpPr>
+        <a:xfrm>
+          <a:off x="0" y="0"/>
+          <a:ext cx="0" cy="0"/>
+          <a:chOff x="0" y="0"/>
+          <a:chExt cx="0" cy="0"/>
+        </a:xfrm>
+      </p:grpSpPr>
       <p:sp>
         <p:nvSpPr>
           <p:cNvPr id="2" name="Rectangle 1"/>
@@ -11691,6 +12108,7 @@
           <a:lstStyle/>
           <a:p>
             <a:pPr algn="ctr"/>
+            <a:endParaRPr/>
           </a:p>
         </p:txBody>
       </p:sp>
@@ -11804,6 +12222,7 @@
           <a:lstStyle/>
           <a:p>
             <a:pPr algn="ctr"/>
+            <a:endParaRPr/>
           </a:p>
         </p:txBody>
       </p:sp>
@@ -11824,7 +12243,7 @@
           <a:noFill/>
         </p:spPr>
         <p:txBody>
-          <a:bodyPr wrap="square" lIns="0" rIns="0" tIns="0" bIns="0" anchor="t">
+          <a:bodyPr wrap="square" lIns="0" tIns="0" rIns="0" bIns="0" anchor="t">
             <a:spAutoFit/>
           </a:bodyPr>
           <a:lstStyle/>
@@ -11903,7 +12322,7 @@
 </file>
 
 <file path=ppt/slides/slide34.xml><?xml version="1.0" encoding="utf-8"?>
-<p:sld xmlns:a="http://schemas.openxmlformats.org/drawingml/2006/main" xmlns:p="http://schemas.openxmlformats.org/presentationml/2006/main" xmlns:r="http://schemas.openxmlformats.org/officeDocument/2006/relationships">
+<p:sld xmlns:a="http://schemas.openxmlformats.org/drawingml/2006/main" xmlns:r="http://schemas.openxmlformats.org/officeDocument/2006/relationships" xmlns:p="http://schemas.openxmlformats.org/presentationml/2006/main">
   <p:cSld>
     <p:bg>
       <p:bgPr>
@@ -11919,7 +12338,14 @@
         <p:cNvGrpSpPr/>
         <p:nvPr/>
       </p:nvGrpSpPr>
-      <p:grpSpPr/>
+      <p:grpSpPr>
+        <a:xfrm>
+          <a:off x="0" y="0"/>
+          <a:ext cx="0" cy="0"/>
+          <a:chOff x="0" y="0"/>
+          <a:chExt cx="0" cy="0"/>
+        </a:xfrm>
+      </p:grpSpPr>
       <p:sp>
         <p:nvSpPr>
           <p:cNvPr id="2" name="Rectangle 1"/>
@@ -11960,6 +12386,7 @@
           <a:lstStyle/>
           <a:p>
             <a:pPr algn="ctr"/>
+            <a:endParaRPr/>
           </a:p>
         </p:txBody>
       </p:sp>
@@ -12073,6 +12500,7 @@
           <a:lstStyle/>
           <a:p>
             <a:pPr algn="ctr"/>
+            <a:endParaRPr/>
           </a:p>
         </p:txBody>
       </p:sp>
@@ -12093,7 +12521,7 @@
           <a:noFill/>
         </p:spPr>
         <p:txBody>
-          <a:bodyPr wrap="square" lIns="0" rIns="0" tIns="0" bIns="0" anchor="t">
+          <a:bodyPr wrap="square" lIns="0" tIns="0" rIns="0" bIns="0" anchor="t">
             <a:spAutoFit/>
           </a:bodyPr>
           <a:lstStyle/>
@@ -12190,7 +12618,7 @@
 </file>
 
 <file path=ppt/slides/slide35.xml><?xml version="1.0" encoding="utf-8"?>
-<p:sld xmlns:a="http://schemas.openxmlformats.org/drawingml/2006/main" xmlns:p="http://schemas.openxmlformats.org/presentationml/2006/main" xmlns:r="http://schemas.openxmlformats.org/officeDocument/2006/relationships">
+<p:sld xmlns:a="http://schemas.openxmlformats.org/drawingml/2006/main" xmlns:r="http://schemas.openxmlformats.org/officeDocument/2006/relationships" xmlns:p="http://schemas.openxmlformats.org/presentationml/2006/main">
   <p:cSld>
     <p:bg>
       <p:bgPr>
@@ -12206,7 +12634,14 @@
         <p:cNvGrpSpPr/>
         <p:nvPr/>
       </p:nvGrpSpPr>
-      <p:grpSpPr/>
+      <p:grpSpPr>
+        <a:xfrm>
+          <a:off x="0" y="0"/>
+          <a:ext cx="0" cy="0"/>
+          <a:chOff x="0" y="0"/>
+          <a:chExt cx="0" cy="0"/>
+        </a:xfrm>
+      </p:grpSpPr>
       <p:sp>
         <p:nvSpPr>
           <p:cNvPr id="2" name="Rectangle 1"/>
@@ -12247,6 +12682,7 @@
           <a:lstStyle/>
           <a:p>
             <a:pPr algn="ctr"/>
+            <a:endParaRPr/>
           </a:p>
         </p:txBody>
       </p:sp>
@@ -12360,6 +12796,7 @@
           <a:lstStyle/>
           <a:p>
             <a:pPr algn="ctr"/>
+            <a:endParaRPr/>
           </a:p>
         </p:txBody>
       </p:sp>
@@ -12380,7 +12817,7 @@
           <a:noFill/>
         </p:spPr>
         <p:txBody>
-          <a:bodyPr wrap="square" lIns="0" rIns="0" tIns="0" bIns="0" anchor="t">
+          <a:bodyPr wrap="square" lIns="0" tIns="0" rIns="0" bIns="0" anchor="t">
             <a:spAutoFit/>
           </a:bodyPr>
           <a:lstStyle/>
@@ -12459,7 +12896,7 @@
 </file>
 
 <file path=ppt/slides/slide36.xml><?xml version="1.0" encoding="utf-8"?>
-<p:sld xmlns:a="http://schemas.openxmlformats.org/drawingml/2006/main" xmlns:p="http://schemas.openxmlformats.org/presentationml/2006/main" xmlns:r="http://schemas.openxmlformats.org/officeDocument/2006/relationships">
+<p:sld xmlns:a="http://schemas.openxmlformats.org/drawingml/2006/main" xmlns:r="http://schemas.openxmlformats.org/officeDocument/2006/relationships" xmlns:p="http://schemas.openxmlformats.org/presentationml/2006/main">
   <p:cSld>
     <p:bg>
       <p:bgPr>
@@ -12475,7 +12912,14 @@
         <p:cNvGrpSpPr/>
         <p:nvPr/>
       </p:nvGrpSpPr>
-      <p:grpSpPr/>
+      <p:grpSpPr>
+        <a:xfrm>
+          <a:off x="0" y="0"/>
+          <a:ext cx="0" cy="0"/>
+          <a:chOff x="0" y="0"/>
+          <a:chExt cx="0" cy="0"/>
+        </a:xfrm>
+      </p:grpSpPr>
       <p:sp>
         <p:nvSpPr>
           <p:cNvPr id="2" name="Rectangle 1"/>
@@ -12516,6 +12960,7 @@
           <a:lstStyle/>
           <a:p>
             <a:pPr algn="ctr"/>
+            <a:endParaRPr/>
           </a:p>
         </p:txBody>
       </p:sp>
@@ -12629,6 +13074,7 @@
           <a:lstStyle/>
           <a:p>
             <a:pPr algn="ctr"/>
+            <a:endParaRPr/>
           </a:p>
         </p:txBody>
       </p:sp>
@@ -12649,7 +13095,7 @@
           <a:noFill/>
         </p:spPr>
         <p:txBody>
-          <a:bodyPr wrap="square" lIns="0" rIns="0" tIns="0" bIns="0" anchor="t">
+          <a:bodyPr wrap="square" lIns="0" tIns="0" rIns="0" bIns="0" anchor="t">
             <a:spAutoFit/>
           </a:bodyPr>
           <a:lstStyle/>
@@ -12746,7 +13192,7 @@
 </file>
 
 <file path=ppt/slides/slide37.xml><?xml version="1.0" encoding="utf-8"?>
-<p:sld xmlns:a="http://schemas.openxmlformats.org/drawingml/2006/main" xmlns:p="http://schemas.openxmlformats.org/presentationml/2006/main" xmlns:r="http://schemas.openxmlformats.org/officeDocument/2006/relationships">
+<p:sld xmlns:a="http://schemas.openxmlformats.org/drawingml/2006/main" xmlns:r="http://schemas.openxmlformats.org/officeDocument/2006/relationships" xmlns:p="http://schemas.openxmlformats.org/presentationml/2006/main">
   <p:cSld>
     <p:bg>
       <p:bgPr>
@@ -12762,7 +13208,14 @@
         <p:cNvGrpSpPr/>
         <p:nvPr/>
       </p:nvGrpSpPr>
-      <p:grpSpPr/>
+      <p:grpSpPr>
+        <a:xfrm>
+          <a:off x="0" y="0"/>
+          <a:ext cx="0" cy="0"/>
+          <a:chOff x="0" y="0"/>
+          <a:chExt cx="0" cy="0"/>
+        </a:xfrm>
+      </p:grpSpPr>
       <p:sp>
         <p:nvSpPr>
           <p:cNvPr id="2" name="Rectangle 1"/>
@@ -12803,6 +13256,7 @@
           <a:lstStyle/>
           <a:p>
             <a:pPr algn="ctr"/>
+            <a:endParaRPr/>
           </a:p>
         </p:txBody>
       </p:sp>
@@ -12916,6 +13370,7 @@
           <a:lstStyle/>
           <a:p>
             <a:pPr algn="ctr"/>
+            <a:endParaRPr/>
           </a:p>
         </p:txBody>
       </p:sp>
@@ -12936,7 +13391,7 @@
           <a:noFill/>
         </p:spPr>
         <p:txBody>
-          <a:bodyPr wrap="square" lIns="0" rIns="0" tIns="0" bIns="0" anchor="t">
+          <a:bodyPr wrap="square" lIns="0" tIns="0" rIns="0" bIns="0" anchor="t">
             <a:spAutoFit/>
           </a:bodyPr>
           <a:lstStyle/>
@@ -12999,7 +13454,7 @@
 </file>
 
 <file path=ppt/slides/slide38.xml><?xml version="1.0" encoding="utf-8"?>
-<p:sld xmlns:a="http://schemas.openxmlformats.org/drawingml/2006/main" xmlns:p="http://schemas.openxmlformats.org/presentationml/2006/main" xmlns:r="http://schemas.openxmlformats.org/officeDocument/2006/relationships">
+<p:sld xmlns:a="http://schemas.openxmlformats.org/drawingml/2006/main" xmlns:r="http://schemas.openxmlformats.org/officeDocument/2006/relationships" xmlns:p="http://schemas.openxmlformats.org/presentationml/2006/main">
   <p:cSld>
     <p:bg>
       <p:bgPr>
@@ -13015,7 +13470,14 @@
         <p:cNvGrpSpPr/>
         <p:nvPr/>
       </p:nvGrpSpPr>
-      <p:grpSpPr/>
+      <p:grpSpPr>
+        <a:xfrm>
+          <a:off x="0" y="0"/>
+          <a:ext cx="0" cy="0"/>
+          <a:chOff x="0" y="0"/>
+          <a:chExt cx="0" cy="0"/>
+        </a:xfrm>
+      </p:grpSpPr>
       <p:sp>
         <p:nvSpPr>
           <p:cNvPr id="2" name="Rectangle 1"/>
@@ -13056,6 +13518,7 @@
           <a:lstStyle/>
           <a:p>
             <a:pPr algn="ctr"/>
+            <a:endParaRPr/>
           </a:p>
         </p:txBody>
       </p:sp>
@@ -13169,6 +13632,7 @@
           <a:lstStyle/>
           <a:p>
             <a:pPr algn="ctr"/>
+            <a:endParaRPr/>
           </a:p>
         </p:txBody>
       </p:sp>
@@ -13189,7 +13653,7 @@
           <a:noFill/>
         </p:spPr>
         <p:txBody>
-          <a:bodyPr wrap="square" lIns="0" rIns="0" tIns="0" bIns="0" anchor="t">
+          <a:bodyPr wrap="square" lIns="0" tIns="0" rIns="0" bIns="0" anchor="t">
             <a:spAutoFit/>
           </a:bodyPr>
           <a:lstStyle/>
@@ -13286,7 +13750,7 @@
 </file>
 
 <file path=ppt/slides/slide39.xml><?xml version="1.0" encoding="utf-8"?>
-<p:sld xmlns:a="http://schemas.openxmlformats.org/drawingml/2006/main" xmlns:p="http://schemas.openxmlformats.org/presentationml/2006/main" xmlns:r="http://schemas.openxmlformats.org/officeDocument/2006/relationships">
+<p:sld xmlns:a="http://schemas.openxmlformats.org/drawingml/2006/main" xmlns:r="http://schemas.openxmlformats.org/officeDocument/2006/relationships" xmlns:p="http://schemas.openxmlformats.org/presentationml/2006/main">
   <p:cSld>
     <p:bg>
       <p:bgPr>
@@ -13302,7 +13766,14 @@
         <p:cNvGrpSpPr/>
         <p:nvPr/>
       </p:nvGrpSpPr>
-      <p:grpSpPr/>
+      <p:grpSpPr>
+        <a:xfrm>
+          <a:off x="0" y="0"/>
+          <a:ext cx="0" cy="0"/>
+          <a:chOff x="0" y="0"/>
+          <a:chExt cx="0" cy="0"/>
+        </a:xfrm>
+      </p:grpSpPr>
       <p:sp>
         <p:nvSpPr>
           <p:cNvPr id="2" name="Rectangle 1"/>
@@ -13343,6 +13814,7 @@
           <a:lstStyle/>
           <a:p>
             <a:pPr algn="ctr"/>
+            <a:endParaRPr/>
           </a:p>
         </p:txBody>
       </p:sp>
@@ -13456,6 +13928,7 @@
           <a:lstStyle/>
           <a:p>
             <a:pPr algn="ctr"/>
+            <a:endParaRPr/>
           </a:p>
         </p:txBody>
       </p:sp>
@@ -13476,7 +13949,7 @@
           <a:noFill/>
         </p:spPr>
         <p:txBody>
-          <a:bodyPr wrap="square" lIns="0" rIns="0" tIns="0" bIns="0" anchor="t">
+          <a:bodyPr wrap="square" lIns="0" tIns="0" rIns="0" bIns="0" anchor="t">
             <a:spAutoFit/>
           </a:bodyPr>
           <a:lstStyle/>
@@ -13555,7 +14028,7 @@
 </file>
 
 <file path=ppt/slides/slide4.xml><?xml version="1.0" encoding="utf-8"?>
-<p:sld xmlns:a="http://schemas.openxmlformats.org/drawingml/2006/main" xmlns:p="http://schemas.openxmlformats.org/presentationml/2006/main" xmlns:r="http://schemas.openxmlformats.org/officeDocument/2006/relationships">
+<p:sld xmlns:a="http://schemas.openxmlformats.org/drawingml/2006/main" xmlns:r="http://schemas.openxmlformats.org/officeDocument/2006/relationships" xmlns:p="http://schemas.openxmlformats.org/presentationml/2006/main">
   <p:cSld>
     <p:bg>
       <p:bgPr>
@@ -13571,7 +14044,14 @@
         <p:cNvGrpSpPr/>
         <p:nvPr/>
       </p:nvGrpSpPr>
-      <p:grpSpPr/>
+      <p:grpSpPr>
+        <a:xfrm>
+          <a:off x="0" y="0"/>
+          <a:ext cx="0" cy="0"/>
+          <a:chOff x="0" y="0"/>
+          <a:chExt cx="0" cy="0"/>
+        </a:xfrm>
+      </p:grpSpPr>
       <p:sp>
         <p:nvSpPr>
           <p:cNvPr id="2" name="Rectangle 1"/>
@@ -13612,6 +14092,7 @@
           <a:lstStyle/>
           <a:p>
             <a:pPr algn="ctr"/>
+            <a:endParaRPr/>
           </a:p>
         </p:txBody>
       </p:sp>
@@ -13725,6 +14206,7 @@
           <a:lstStyle/>
           <a:p>
             <a:pPr algn="ctr"/>
+            <a:endParaRPr/>
           </a:p>
         </p:txBody>
       </p:sp>
@@ -13745,7 +14227,7 @@
           <a:noFill/>
         </p:spPr>
         <p:txBody>
-          <a:bodyPr wrap="square" lIns="0" rIns="0" tIns="0" bIns="0" anchor="t">
+          <a:bodyPr wrap="square" lIns="0" tIns="0" rIns="0" bIns="0" anchor="t">
             <a:spAutoFit/>
           </a:bodyPr>
           <a:lstStyle/>
@@ -13824,7 +14306,7 @@
 </file>
 
 <file path=ppt/slides/slide40.xml><?xml version="1.0" encoding="utf-8"?>
-<p:sld xmlns:a="http://schemas.openxmlformats.org/drawingml/2006/main" xmlns:p="http://schemas.openxmlformats.org/presentationml/2006/main" xmlns:r="http://schemas.openxmlformats.org/officeDocument/2006/relationships">
+<p:sld xmlns:a="http://schemas.openxmlformats.org/drawingml/2006/main" xmlns:r="http://schemas.openxmlformats.org/officeDocument/2006/relationships" xmlns:p="http://schemas.openxmlformats.org/presentationml/2006/main">
   <p:cSld>
     <p:bg>
       <p:bgPr>
@@ -13840,7 +14322,14 @@
         <p:cNvGrpSpPr/>
         <p:nvPr/>
       </p:nvGrpSpPr>
-      <p:grpSpPr/>
+      <p:grpSpPr>
+        <a:xfrm>
+          <a:off x="0" y="0"/>
+          <a:ext cx="0" cy="0"/>
+          <a:chOff x="0" y="0"/>
+          <a:chExt cx="0" cy="0"/>
+        </a:xfrm>
+      </p:grpSpPr>
       <p:sp>
         <p:nvSpPr>
           <p:cNvPr id="2" name="Rectangle 1"/>
@@ -13881,6 +14370,7 @@
           <a:lstStyle/>
           <a:p>
             <a:pPr algn="ctr"/>
+            <a:endParaRPr/>
           </a:p>
         </p:txBody>
       </p:sp>
@@ -13994,6 +14484,7 @@
           <a:lstStyle/>
           <a:p>
             <a:pPr algn="ctr"/>
+            <a:endParaRPr/>
           </a:p>
         </p:txBody>
       </p:sp>
@@ -14014,7 +14505,7 @@
           <a:noFill/>
         </p:spPr>
         <p:txBody>
-          <a:bodyPr wrap="square" lIns="0" rIns="0" tIns="0" bIns="0" anchor="t">
+          <a:bodyPr wrap="square" lIns="0" tIns="0" rIns="0" bIns="0" anchor="t">
             <a:spAutoFit/>
           </a:bodyPr>
           <a:lstStyle/>
@@ -14111,7 +14602,7 @@
 </file>
 
 <file path=ppt/slides/slide41.xml><?xml version="1.0" encoding="utf-8"?>
-<p:sld xmlns:a="http://schemas.openxmlformats.org/drawingml/2006/main" xmlns:p="http://schemas.openxmlformats.org/presentationml/2006/main" xmlns:r="http://schemas.openxmlformats.org/officeDocument/2006/relationships">
+<p:sld xmlns:a="http://schemas.openxmlformats.org/drawingml/2006/main" xmlns:r="http://schemas.openxmlformats.org/officeDocument/2006/relationships" xmlns:p="http://schemas.openxmlformats.org/presentationml/2006/main">
   <p:cSld>
     <p:bg>
       <p:bgPr>
@@ -14127,7 +14618,14 @@
         <p:cNvGrpSpPr/>
         <p:nvPr/>
       </p:nvGrpSpPr>
-      <p:grpSpPr/>
+      <p:grpSpPr>
+        <a:xfrm>
+          <a:off x="0" y="0"/>
+          <a:ext cx="0" cy="0"/>
+          <a:chOff x="0" y="0"/>
+          <a:chExt cx="0" cy="0"/>
+        </a:xfrm>
+      </p:grpSpPr>
       <p:sp>
         <p:nvSpPr>
           <p:cNvPr id="2" name="Rectangle 1"/>
@@ -14168,6 +14666,7 @@
           <a:lstStyle/>
           <a:p>
             <a:pPr algn="ctr"/>
+            <a:endParaRPr/>
           </a:p>
         </p:txBody>
       </p:sp>
@@ -14281,6 +14780,7 @@
           <a:lstStyle/>
           <a:p>
             <a:pPr algn="ctr"/>
+            <a:endParaRPr/>
           </a:p>
         </p:txBody>
       </p:sp>
@@ -14301,7 +14801,7 @@
           <a:noFill/>
         </p:spPr>
         <p:txBody>
-          <a:bodyPr wrap="square" lIns="0" rIns="0" tIns="0" bIns="0" anchor="t">
+          <a:bodyPr wrap="square" lIns="0" tIns="0" rIns="0" bIns="0" anchor="t">
             <a:spAutoFit/>
           </a:bodyPr>
           <a:lstStyle/>
@@ -14414,7 +14914,7 @@
 </file>
 
 <file path=ppt/slides/slide42.xml><?xml version="1.0" encoding="utf-8"?>
-<p:sld xmlns:a="http://schemas.openxmlformats.org/drawingml/2006/main" xmlns:p="http://schemas.openxmlformats.org/presentationml/2006/main" xmlns:r="http://schemas.openxmlformats.org/officeDocument/2006/relationships">
+<p:sld xmlns:a="http://schemas.openxmlformats.org/drawingml/2006/main" xmlns:r="http://schemas.openxmlformats.org/officeDocument/2006/relationships" xmlns:p="http://schemas.openxmlformats.org/presentationml/2006/main">
   <p:cSld>
     <p:bg>
       <p:bgPr>
@@ -14430,7 +14930,14 @@
         <p:cNvGrpSpPr/>
         <p:nvPr/>
       </p:nvGrpSpPr>
-      <p:grpSpPr/>
+      <p:grpSpPr>
+        <a:xfrm>
+          <a:off x="0" y="0"/>
+          <a:ext cx="0" cy="0"/>
+          <a:chOff x="0" y="0"/>
+          <a:chExt cx="0" cy="0"/>
+        </a:xfrm>
+      </p:grpSpPr>
       <p:sp>
         <p:nvSpPr>
           <p:cNvPr id="2" name="Rectangle 1"/>
@@ -14471,6 +14978,7 @@
           <a:lstStyle/>
           <a:p>
             <a:pPr algn="ctr"/>
+            <a:endParaRPr/>
           </a:p>
         </p:txBody>
       </p:sp>
@@ -14584,6 +15092,7 @@
           <a:lstStyle/>
           <a:p>
             <a:pPr algn="ctr"/>
+            <a:endParaRPr/>
           </a:p>
         </p:txBody>
       </p:sp>
@@ -14604,7 +15113,7 @@
           <a:noFill/>
         </p:spPr>
         <p:txBody>
-          <a:bodyPr wrap="square" lIns="0" rIns="0" tIns="0" bIns="0" anchor="t">
+          <a:bodyPr wrap="square" lIns="0" tIns="0" rIns="0" bIns="0" anchor="t">
             <a:spAutoFit/>
           </a:bodyPr>
           <a:lstStyle/>
@@ -14701,7 +15210,7 @@
 </file>
 
 <file path=ppt/slides/slide43.xml><?xml version="1.0" encoding="utf-8"?>
-<p:sld xmlns:a="http://schemas.openxmlformats.org/drawingml/2006/main" xmlns:p="http://schemas.openxmlformats.org/presentationml/2006/main" xmlns:r="http://schemas.openxmlformats.org/officeDocument/2006/relationships">
+<p:sld xmlns:a="http://schemas.openxmlformats.org/drawingml/2006/main" xmlns:r="http://schemas.openxmlformats.org/officeDocument/2006/relationships" xmlns:p="http://schemas.openxmlformats.org/presentationml/2006/main">
   <p:cSld>
     <p:bg>
       <p:bgPr>
@@ -14717,7 +15226,14 @@
         <p:cNvGrpSpPr/>
         <p:nvPr/>
       </p:nvGrpSpPr>
-      <p:grpSpPr/>
+      <p:grpSpPr>
+        <a:xfrm>
+          <a:off x="0" y="0"/>
+          <a:ext cx="0" cy="0"/>
+          <a:chOff x="0" y="0"/>
+          <a:chExt cx="0" cy="0"/>
+        </a:xfrm>
+      </p:grpSpPr>
       <p:sp>
         <p:nvSpPr>
           <p:cNvPr id="2" name="Rectangle 1"/>
@@ -14758,6 +15274,7 @@
           <a:lstStyle/>
           <a:p>
             <a:pPr algn="ctr"/>
+            <a:endParaRPr/>
           </a:p>
         </p:txBody>
       </p:sp>
@@ -14871,6 +15388,7 @@
           <a:lstStyle/>
           <a:p>
             <a:pPr algn="ctr"/>
+            <a:endParaRPr/>
           </a:p>
         </p:txBody>
       </p:sp>
@@ -14891,7 +15409,7 @@
           <a:noFill/>
         </p:spPr>
         <p:txBody>
-          <a:bodyPr wrap="square" lIns="0" rIns="0" tIns="0" bIns="0" anchor="t">
+          <a:bodyPr wrap="square" lIns="0" tIns="0" rIns="0" bIns="0" anchor="t">
             <a:spAutoFit/>
           </a:bodyPr>
           <a:lstStyle/>
@@ -15004,7 +15522,7 @@
 </file>
 
 <file path=ppt/slides/slide44.xml><?xml version="1.0" encoding="utf-8"?>
-<p:sld xmlns:a="http://schemas.openxmlformats.org/drawingml/2006/main" xmlns:p="http://schemas.openxmlformats.org/presentationml/2006/main" xmlns:r="http://schemas.openxmlformats.org/officeDocument/2006/relationships">
+<p:sld xmlns:a="http://schemas.openxmlformats.org/drawingml/2006/main" xmlns:r="http://schemas.openxmlformats.org/officeDocument/2006/relationships" xmlns:p="http://schemas.openxmlformats.org/presentationml/2006/main">
   <p:cSld>
     <p:bg>
       <p:bgPr>
@@ -15020,7 +15538,14 @@
         <p:cNvGrpSpPr/>
         <p:nvPr/>
       </p:nvGrpSpPr>
-      <p:grpSpPr/>
+      <p:grpSpPr>
+        <a:xfrm>
+          <a:off x="0" y="0"/>
+          <a:ext cx="0" cy="0"/>
+          <a:chOff x="0" y="0"/>
+          <a:chExt cx="0" cy="0"/>
+        </a:xfrm>
+      </p:grpSpPr>
       <p:sp>
         <p:nvSpPr>
           <p:cNvPr id="2" name="Rectangle 1"/>
@@ -15061,6 +15586,7 @@
           <a:lstStyle/>
           <a:p>
             <a:pPr algn="ctr"/>
+            <a:endParaRPr/>
           </a:p>
         </p:txBody>
       </p:sp>
@@ -15174,6 +15700,7 @@
           <a:lstStyle/>
           <a:p>
             <a:pPr algn="ctr"/>
+            <a:endParaRPr/>
           </a:p>
         </p:txBody>
       </p:sp>
@@ -15194,7 +15721,7 @@
           <a:noFill/>
         </p:spPr>
         <p:txBody>
-          <a:bodyPr wrap="square" lIns="0" rIns="0" tIns="0" bIns="0" anchor="t">
+          <a:bodyPr wrap="square" lIns="0" tIns="0" rIns="0" bIns="0" anchor="t">
             <a:spAutoFit/>
           </a:bodyPr>
           <a:lstStyle/>
@@ -15307,7 +15834,7 @@
 </file>
 
 <file path=ppt/slides/slide45.xml><?xml version="1.0" encoding="utf-8"?>
-<p:sld xmlns:a="http://schemas.openxmlformats.org/drawingml/2006/main" xmlns:p="http://schemas.openxmlformats.org/presentationml/2006/main" xmlns:r="http://schemas.openxmlformats.org/officeDocument/2006/relationships">
+<p:sld xmlns:a="http://schemas.openxmlformats.org/drawingml/2006/main" xmlns:r="http://schemas.openxmlformats.org/officeDocument/2006/relationships" xmlns:p="http://schemas.openxmlformats.org/presentationml/2006/main">
   <p:cSld>
     <p:bg>
       <p:bgPr>
@@ -15323,7 +15850,14 @@
         <p:cNvGrpSpPr/>
         <p:nvPr/>
       </p:nvGrpSpPr>
-      <p:grpSpPr/>
+      <p:grpSpPr>
+        <a:xfrm>
+          <a:off x="0" y="0"/>
+          <a:ext cx="0" cy="0"/>
+          <a:chOff x="0" y="0"/>
+          <a:chExt cx="0" cy="0"/>
+        </a:xfrm>
+      </p:grpSpPr>
       <p:sp>
         <p:nvSpPr>
           <p:cNvPr id="2" name="Rectangle 1"/>
@@ -15364,6 +15898,7 @@
           <a:lstStyle/>
           <a:p>
             <a:pPr algn="ctr"/>
+            <a:endParaRPr/>
           </a:p>
         </p:txBody>
       </p:sp>
@@ -15477,6 +16012,7 @@
           <a:lstStyle/>
           <a:p>
             <a:pPr algn="ctr"/>
+            <a:endParaRPr/>
           </a:p>
         </p:txBody>
       </p:sp>
@@ -15497,7 +16033,7 @@
           <a:noFill/>
         </p:spPr>
         <p:txBody>
-          <a:bodyPr wrap="square" lIns="0" rIns="0" tIns="0" bIns="0" anchor="t">
+          <a:bodyPr wrap="square" lIns="0" tIns="0" rIns="0" bIns="0" anchor="t">
             <a:spAutoFit/>
           </a:bodyPr>
           <a:lstStyle/>
@@ -15576,7 +16112,7 @@
 </file>
 
 <file path=ppt/slides/slide46.xml><?xml version="1.0" encoding="utf-8"?>
-<p:sld xmlns:a="http://schemas.openxmlformats.org/drawingml/2006/main" xmlns:p="http://schemas.openxmlformats.org/presentationml/2006/main" xmlns:r="http://schemas.openxmlformats.org/officeDocument/2006/relationships">
+<p:sld xmlns:a="http://schemas.openxmlformats.org/drawingml/2006/main" xmlns:r="http://schemas.openxmlformats.org/officeDocument/2006/relationships" xmlns:p="http://schemas.openxmlformats.org/presentationml/2006/main">
   <p:cSld>
     <p:bg>
       <p:bgPr>
@@ -15592,7 +16128,14 @@
         <p:cNvGrpSpPr/>
         <p:nvPr/>
       </p:nvGrpSpPr>
-      <p:grpSpPr/>
+      <p:grpSpPr>
+        <a:xfrm>
+          <a:off x="0" y="0"/>
+          <a:ext cx="0" cy="0"/>
+          <a:chOff x="0" y="0"/>
+          <a:chExt cx="0" cy="0"/>
+        </a:xfrm>
+      </p:grpSpPr>
       <p:sp>
         <p:nvSpPr>
           <p:cNvPr id="2" name="Rectangle 1"/>
@@ -15633,6 +16176,7 @@
           <a:lstStyle/>
           <a:p>
             <a:pPr algn="ctr"/>
+            <a:endParaRPr/>
           </a:p>
         </p:txBody>
       </p:sp>
@@ -15746,6 +16290,7 @@
           <a:lstStyle/>
           <a:p>
             <a:pPr algn="ctr"/>
+            <a:endParaRPr/>
           </a:p>
         </p:txBody>
       </p:sp>
@@ -15927,6 +16472,7 @@
           <a:lstStyle/>
           <a:p>
             <a:pPr algn="ctr"/>
+            <a:endParaRPr/>
           </a:p>
         </p:txBody>
       </p:sp>
@@ -16108,6 +16654,7 @@
           <a:lstStyle/>
           <a:p>
             <a:pPr algn="ctr"/>
+            <a:endParaRPr/>
           </a:p>
         </p:txBody>
       </p:sp>
@@ -16289,6 +16836,7 @@
           <a:lstStyle/>
           <a:p>
             <a:pPr algn="ctr"/>
+            <a:endParaRPr/>
           </a:p>
         </p:txBody>
       </p:sp>
@@ -16470,6 +17018,7 @@
           <a:lstStyle/>
           <a:p>
             <a:pPr algn="ctr"/>
+            <a:endParaRPr/>
           </a:p>
         </p:txBody>
       </p:sp>
@@ -16651,6 +17200,7 @@
           <a:lstStyle/>
           <a:p>
             <a:pPr algn="ctr"/>
+            <a:endParaRPr/>
           </a:p>
         </p:txBody>
       </p:sp>
@@ -16833,7 +17383,7 @@
 </file>
 
 <file path=ppt/slides/slide47.xml><?xml version="1.0" encoding="utf-8"?>
-<p:sld xmlns:a="http://schemas.openxmlformats.org/drawingml/2006/main" xmlns:p="http://schemas.openxmlformats.org/presentationml/2006/main" xmlns:r="http://schemas.openxmlformats.org/officeDocument/2006/relationships">
+<p:sld xmlns:a="http://schemas.openxmlformats.org/drawingml/2006/main" xmlns:r="http://schemas.openxmlformats.org/officeDocument/2006/relationships" xmlns:p="http://schemas.openxmlformats.org/presentationml/2006/main">
   <p:cSld>
     <p:bg>
       <p:bgPr>
@@ -16849,7 +17399,14 @@
         <p:cNvGrpSpPr/>
         <p:nvPr/>
       </p:nvGrpSpPr>
-      <p:grpSpPr/>
+      <p:grpSpPr>
+        <a:xfrm>
+          <a:off x="0" y="0"/>
+          <a:ext cx="0" cy="0"/>
+          <a:chOff x="0" y="0"/>
+          <a:chExt cx="0" cy="0"/>
+        </a:xfrm>
+      </p:grpSpPr>
       <p:sp>
         <p:nvSpPr>
           <p:cNvPr id="2" name="Rectangle 1"/>
@@ -16890,6 +17447,7 @@
           <a:lstStyle/>
           <a:p>
             <a:pPr algn="ctr"/>
+            <a:endParaRPr/>
           </a:p>
         </p:txBody>
       </p:sp>
@@ -17003,6 +17561,7 @@
           <a:lstStyle/>
           <a:p>
             <a:pPr algn="ctr"/>
+            <a:endParaRPr/>
           </a:p>
         </p:txBody>
       </p:sp>
@@ -17023,7 +17582,7 @@
           <a:noFill/>
         </p:spPr>
         <p:txBody>
-          <a:bodyPr wrap="square" lIns="0" rIns="0" tIns="0" bIns="0" anchor="t">
+          <a:bodyPr wrap="square" lIns="0" tIns="0" rIns="0" bIns="0" anchor="t">
             <a:spAutoFit/>
           </a:bodyPr>
           <a:lstStyle/>
@@ -17102,7 +17661,7 @@
 </file>
 
 <file path=ppt/slides/slide48.xml><?xml version="1.0" encoding="utf-8"?>
-<p:sld xmlns:a="http://schemas.openxmlformats.org/drawingml/2006/main" xmlns:p="http://schemas.openxmlformats.org/presentationml/2006/main" xmlns:r="http://schemas.openxmlformats.org/officeDocument/2006/relationships">
+<p:sld xmlns:a="http://schemas.openxmlformats.org/drawingml/2006/main" xmlns:r="http://schemas.openxmlformats.org/officeDocument/2006/relationships" xmlns:p="http://schemas.openxmlformats.org/presentationml/2006/main">
   <p:cSld>
     <p:bg>
       <p:bgPr>
@@ -17118,7 +17677,14 @@
         <p:cNvGrpSpPr/>
         <p:nvPr/>
       </p:nvGrpSpPr>
-      <p:grpSpPr/>
+      <p:grpSpPr>
+        <a:xfrm>
+          <a:off x="0" y="0"/>
+          <a:ext cx="0" cy="0"/>
+          <a:chOff x="0" y="0"/>
+          <a:chExt cx="0" cy="0"/>
+        </a:xfrm>
+      </p:grpSpPr>
       <p:sp>
         <p:nvSpPr>
           <p:cNvPr id="2" name="Rectangle 1"/>
@@ -17159,6 +17725,7 @@
           <a:lstStyle/>
           <a:p>
             <a:pPr algn="ctr"/>
+            <a:endParaRPr/>
           </a:p>
         </p:txBody>
       </p:sp>
@@ -17272,6 +17839,7 @@
           <a:lstStyle/>
           <a:p>
             <a:pPr algn="ctr"/>
+            <a:endParaRPr/>
           </a:p>
         </p:txBody>
       </p:sp>
@@ -17351,6 +17919,7 @@
           <a:lstStyle/>
           <a:p>
             <a:pPr algn="ctr"/>
+            <a:endParaRPr/>
           </a:p>
         </p:txBody>
       </p:sp>
@@ -17535,6 +18104,7 @@
           <a:lstStyle/>
           <a:p>
             <a:pPr algn="ctr"/>
+            <a:endParaRPr/>
           </a:p>
         </p:txBody>
       </p:sp>
@@ -17720,7 +18290,7 @@
 </file>
 
 <file path=ppt/slides/slide49.xml><?xml version="1.0" encoding="utf-8"?>
-<p:sld xmlns:a="http://schemas.openxmlformats.org/drawingml/2006/main" xmlns:p="http://schemas.openxmlformats.org/presentationml/2006/main" xmlns:r="http://schemas.openxmlformats.org/officeDocument/2006/relationships">
+<p:sld xmlns:a="http://schemas.openxmlformats.org/drawingml/2006/main" xmlns:r="http://schemas.openxmlformats.org/officeDocument/2006/relationships" xmlns:p="http://schemas.openxmlformats.org/presentationml/2006/main">
   <p:cSld>
     <p:bg>
       <p:bgPr>
@@ -17736,7 +18306,14 @@
         <p:cNvGrpSpPr/>
         <p:nvPr/>
       </p:nvGrpSpPr>
-      <p:grpSpPr/>
+      <p:grpSpPr>
+        <a:xfrm>
+          <a:off x="0" y="0"/>
+          <a:ext cx="0" cy="0"/>
+          <a:chOff x="0" y="0"/>
+          <a:chExt cx="0" cy="0"/>
+        </a:xfrm>
+      </p:grpSpPr>
       <p:sp>
         <p:nvSpPr>
           <p:cNvPr id="2" name="Rectangle 1"/>
@@ -17777,6 +18354,7 @@
           <a:lstStyle/>
           <a:p>
             <a:pPr algn="ctr"/>
+            <a:endParaRPr/>
           </a:p>
         </p:txBody>
       </p:sp>
@@ -17890,6 +18468,7 @@
           <a:lstStyle/>
           <a:p>
             <a:pPr algn="ctr"/>
+            <a:endParaRPr/>
           </a:p>
         </p:txBody>
       </p:sp>
@@ -17910,7 +18489,7 @@
           <a:noFill/>
         </p:spPr>
         <p:txBody>
-          <a:bodyPr wrap="square" lIns="0" rIns="0" tIns="0" bIns="0" anchor="t">
+          <a:bodyPr wrap="square" lIns="0" tIns="0" rIns="0" bIns="0" anchor="t">
             <a:spAutoFit/>
           </a:bodyPr>
           <a:lstStyle/>
@@ -17989,7 +18568,7 @@
 </file>
 
 <file path=ppt/slides/slide5.xml><?xml version="1.0" encoding="utf-8"?>
-<p:sld xmlns:a="http://schemas.openxmlformats.org/drawingml/2006/main" xmlns:p="http://schemas.openxmlformats.org/presentationml/2006/main" xmlns:r="http://schemas.openxmlformats.org/officeDocument/2006/relationships">
+<p:sld xmlns:a="http://schemas.openxmlformats.org/drawingml/2006/main" xmlns:r="http://schemas.openxmlformats.org/officeDocument/2006/relationships" xmlns:p="http://schemas.openxmlformats.org/presentationml/2006/main">
   <p:cSld>
     <p:bg>
       <p:bgPr>
@@ -18005,7 +18584,14 @@
         <p:cNvGrpSpPr/>
         <p:nvPr/>
       </p:nvGrpSpPr>
-      <p:grpSpPr/>
+      <p:grpSpPr>
+        <a:xfrm>
+          <a:off x="0" y="0"/>
+          <a:ext cx="0" cy="0"/>
+          <a:chOff x="0" y="0"/>
+          <a:chExt cx="0" cy="0"/>
+        </a:xfrm>
+      </p:grpSpPr>
       <p:sp>
         <p:nvSpPr>
           <p:cNvPr id="2" name="Rectangle 1"/>
@@ -18046,6 +18632,7 @@
           <a:lstStyle/>
           <a:p>
             <a:pPr algn="ctr"/>
+            <a:endParaRPr/>
           </a:p>
         </p:txBody>
       </p:sp>
@@ -18159,6 +18746,7 @@
           <a:lstStyle/>
           <a:p>
             <a:pPr algn="ctr"/>
+            <a:endParaRPr/>
           </a:p>
         </p:txBody>
       </p:sp>
@@ -18179,7 +18767,7 @@
           <a:noFill/>
         </p:spPr>
         <p:txBody>
-          <a:bodyPr wrap="square" lIns="0" rIns="0" tIns="0" bIns="0" anchor="t">
+          <a:bodyPr wrap="square" lIns="0" tIns="0" rIns="0" bIns="0" anchor="t">
             <a:spAutoFit/>
           </a:bodyPr>
           <a:lstStyle/>
@@ -18258,7 +18846,7 @@
 </file>
 
 <file path=ppt/slides/slide50.xml><?xml version="1.0" encoding="utf-8"?>
-<p:sld xmlns:a="http://schemas.openxmlformats.org/drawingml/2006/main" xmlns:p="http://schemas.openxmlformats.org/presentationml/2006/main" xmlns:r="http://schemas.openxmlformats.org/officeDocument/2006/relationships">
+<p:sld xmlns:a="http://schemas.openxmlformats.org/drawingml/2006/main" xmlns:r="http://schemas.openxmlformats.org/officeDocument/2006/relationships" xmlns:p="http://schemas.openxmlformats.org/presentationml/2006/main">
   <p:cSld>
     <p:bg>
       <p:bgPr>
@@ -18274,7 +18862,14 @@
         <p:cNvGrpSpPr/>
         <p:nvPr/>
       </p:nvGrpSpPr>
-      <p:grpSpPr/>
+      <p:grpSpPr>
+        <a:xfrm>
+          <a:off x="0" y="0"/>
+          <a:ext cx="0" cy="0"/>
+          <a:chOff x="0" y="0"/>
+          <a:chExt cx="0" cy="0"/>
+        </a:xfrm>
+      </p:grpSpPr>
       <p:sp>
         <p:nvSpPr>
           <p:cNvPr id="2" name="Rectangle 1"/>
@@ -18315,6 +18910,7 @@
           <a:lstStyle/>
           <a:p>
             <a:pPr algn="ctr"/>
+            <a:endParaRPr/>
           </a:p>
         </p:txBody>
       </p:sp>
@@ -18428,6 +19024,7 @@
           <a:lstStyle/>
           <a:p>
             <a:pPr algn="ctr"/>
+            <a:endParaRPr/>
           </a:p>
         </p:txBody>
       </p:sp>
@@ -18448,7 +19045,7 @@
           <a:noFill/>
         </p:spPr>
         <p:txBody>
-          <a:bodyPr wrap="square" lIns="0" rIns="0" tIns="0" bIns="0" anchor="t">
+          <a:bodyPr wrap="square" lIns="0" tIns="0" rIns="0" bIns="0" anchor="t">
             <a:spAutoFit/>
           </a:bodyPr>
           <a:lstStyle/>
@@ -18527,7 +19124,7 @@
 </file>
 
 <file path=ppt/slides/slide51.xml><?xml version="1.0" encoding="utf-8"?>
-<p:sld xmlns:a="http://schemas.openxmlformats.org/drawingml/2006/main" xmlns:p="http://schemas.openxmlformats.org/presentationml/2006/main" xmlns:r="http://schemas.openxmlformats.org/officeDocument/2006/relationships">
+<p:sld xmlns:a="http://schemas.openxmlformats.org/drawingml/2006/main" xmlns:r="http://schemas.openxmlformats.org/officeDocument/2006/relationships" xmlns:p="http://schemas.openxmlformats.org/presentationml/2006/main">
   <p:cSld>
     <p:bg>
       <p:bgPr>
@@ -18543,7 +19140,14 @@
         <p:cNvGrpSpPr/>
         <p:nvPr/>
       </p:nvGrpSpPr>
-      <p:grpSpPr/>
+      <p:grpSpPr>
+        <a:xfrm>
+          <a:off x="0" y="0"/>
+          <a:ext cx="0" cy="0"/>
+          <a:chOff x="0" y="0"/>
+          <a:chExt cx="0" cy="0"/>
+        </a:xfrm>
+      </p:grpSpPr>
       <p:sp>
         <p:nvSpPr>
           <p:cNvPr id="2" name="Rectangle 1"/>
@@ -18584,6 +19188,7 @@
           <a:lstStyle/>
           <a:p>
             <a:pPr algn="ctr"/>
+            <a:endParaRPr/>
           </a:p>
         </p:txBody>
       </p:sp>
@@ -18697,6 +19302,7 @@
           <a:lstStyle/>
           <a:p>
             <a:pPr algn="ctr"/>
+            <a:endParaRPr/>
           </a:p>
         </p:txBody>
       </p:sp>
@@ -18717,7 +19323,7 @@
           <a:noFill/>
         </p:spPr>
         <p:txBody>
-          <a:bodyPr wrap="square" lIns="0" rIns="0" tIns="0" bIns="0" anchor="t">
+          <a:bodyPr wrap="square" lIns="0" tIns="0" rIns="0" bIns="0" anchor="t">
             <a:spAutoFit/>
           </a:bodyPr>
           <a:lstStyle/>
@@ -18796,7 +19402,7 @@
 </file>
 
 <file path=ppt/slides/slide52.xml><?xml version="1.0" encoding="utf-8"?>
-<p:sld xmlns:a="http://schemas.openxmlformats.org/drawingml/2006/main" xmlns:p="http://schemas.openxmlformats.org/presentationml/2006/main" xmlns:r="http://schemas.openxmlformats.org/officeDocument/2006/relationships">
+<p:sld xmlns:a="http://schemas.openxmlformats.org/drawingml/2006/main" xmlns:r="http://schemas.openxmlformats.org/officeDocument/2006/relationships" xmlns:p="http://schemas.openxmlformats.org/presentationml/2006/main">
   <p:cSld>
     <p:bg>
       <p:bgPr>
@@ -18812,7 +19418,14 @@
         <p:cNvGrpSpPr/>
         <p:nvPr/>
       </p:nvGrpSpPr>
-      <p:grpSpPr/>
+      <p:grpSpPr>
+        <a:xfrm>
+          <a:off x="0" y="0"/>
+          <a:ext cx="0" cy="0"/>
+          <a:chOff x="0" y="0"/>
+          <a:chExt cx="0" cy="0"/>
+        </a:xfrm>
+      </p:grpSpPr>
       <p:sp>
         <p:nvSpPr>
           <p:cNvPr id="2" name="Rectangle 1"/>
@@ -18853,6 +19466,7 @@
           <a:lstStyle/>
           <a:p>
             <a:pPr algn="ctr"/>
+            <a:endParaRPr/>
           </a:p>
         </p:txBody>
       </p:sp>
@@ -18966,6 +19580,7 @@
           <a:lstStyle/>
           <a:p>
             <a:pPr algn="ctr"/>
+            <a:endParaRPr/>
           </a:p>
         </p:txBody>
       </p:sp>
@@ -18986,7 +19601,7 @@
           <a:noFill/>
         </p:spPr>
         <p:txBody>
-          <a:bodyPr wrap="square" lIns="0" rIns="0" tIns="0" bIns="0" anchor="t">
+          <a:bodyPr wrap="square" lIns="0" tIns="0" rIns="0" bIns="0" anchor="t">
             <a:spAutoFit/>
           </a:bodyPr>
           <a:lstStyle/>
@@ -19065,7 +19680,7 @@
 </file>
 
 <file path=ppt/slides/slide53.xml><?xml version="1.0" encoding="utf-8"?>
-<p:sld xmlns:a="http://schemas.openxmlformats.org/drawingml/2006/main" xmlns:p="http://schemas.openxmlformats.org/presentationml/2006/main" xmlns:r="http://schemas.openxmlformats.org/officeDocument/2006/relationships">
+<p:sld xmlns:a="http://schemas.openxmlformats.org/drawingml/2006/main" xmlns:r="http://schemas.openxmlformats.org/officeDocument/2006/relationships" xmlns:p="http://schemas.openxmlformats.org/presentationml/2006/main">
   <p:cSld>
     <p:bg>
       <p:bgPr>
@@ -19081,7 +19696,14 @@
         <p:cNvGrpSpPr/>
         <p:nvPr/>
       </p:nvGrpSpPr>
-      <p:grpSpPr/>
+      <p:grpSpPr>
+        <a:xfrm>
+          <a:off x="0" y="0"/>
+          <a:ext cx="0" cy="0"/>
+          <a:chOff x="0" y="0"/>
+          <a:chExt cx="0" cy="0"/>
+        </a:xfrm>
+      </p:grpSpPr>
       <p:sp>
         <p:nvSpPr>
           <p:cNvPr id="2" name="Rectangle 1"/>
@@ -19122,6 +19744,7 @@
           <a:lstStyle/>
           <a:p>
             <a:pPr algn="ctr"/>
+            <a:endParaRPr/>
           </a:p>
         </p:txBody>
       </p:sp>
@@ -19235,6 +19858,7 @@
           <a:lstStyle/>
           <a:p>
             <a:pPr algn="ctr"/>
+            <a:endParaRPr/>
           </a:p>
         </p:txBody>
       </p:sp>
@@ -19255,7 +19879,7 @@
           <a:noFill/>
         </p:spPr>
         <p:txBody>
-          <a:bodyPr wrap="square" lIns="0" rIns="0" tIns="0" bIns="0" anchor="t">
+          <a:bodyPr wrap="square" lIns="0" tIns="0" rIns="0" bIns="0" anchor="t">
             <a:spAutoFit/>
           </a:bodyPr>
           <a:lstStyle/>
@@ -19318,7 +19942,7 @@
 </file>
 
 <file path=ppt/slides/slide54.xml><?xml version="1.0" encoding="utf-8"?>
-<p:sld xmlns:a="http://schemas.openxmlformats.org/drawingml/2006/main" xmlns:p="http://schemas.openxmlformats.org/presentationml/2006/main" xmlns:r="http://schemas.openxmlformats.org/officeDocument/2006/relationships">
+<p:sld xmlns:a="http://schemas.openxmlformats.org/drawingml/2006/main" xmlns:r="http://schemas.openxmlformats.org/officeDocument/2006/relationships" xmlns:p="http://schemas.openxmlformats.org/presentationml/2006/main">
   <p:cSld>
     <p:bg>
       <p:bgPr>
@@ -19334,7 +19958,14 @@
         <p:cNvGrpSpPr/>
         <p:nvPr/>
       </p:nvGrpSpPr>
-      <p:grpSpPr/>
+      <p:grpSpPr>
+        <a:xfrm>
+          <a:off x="0" y="0"/>
+          <a:ext cx="0" cy="0"/>
+          <a:chOff x="0" y="0"/>
+          <a:chExt cx="0" cy="0"/>
+        </a:xfrm>
+      </p:grpSpPr>
       <p:sp>
         <p:nvSpPr>
           <p:cNvPr id="2" name="Rectangle 1"/>
@@ -19375,6 +20006,7 @@
           <a:lstStyle/>
           <a:p>
             <a:pPr algn="ctr"/>
+            <a:endParaRPr/>
           </a:p>
         </p:txBody>
       </p:sp>
@@ -19488,6 +20120,7 @@
           <a:lstStyle/>
           <a:p>
             <a:pPr algn="ctr"/>
+            <a:endParaRPr/>
           </a:p>
         </p:txBody>
       </p:sp>
@@ -19508,7 +20141,7 @@
           <a:noFill/>
         </p:spPr>
         <p:txBody>
-          <a:bodyPr wrap="square" lIns="0" rIns="0" tIns="0" bIns="0" anchor="t">
+          <a:bodyPr wrap="square" lIns="0" tIns="0" rIns="0" bIns="0" anchor="t">
             <a:spAutoFit/>
           </a:bodyPr>
           <a:lstStyle/>
@@ -19571,7 +20204,7 @@
 </file>
 
 <file path=ppt/slides/slide55.xml><?xml version="1.0" encoding="utf-8"?>
-<p:sld xmlns:a="http://schemas.openxmlformats.org/drawingml/2006/main" xmlns:p="http://schemas.openxmlformats.org/presentationml/2006/main" xmlns:r="http://schemas.openxmlformats.org/officeDocument/2006/relationships">
+<p:sld xmlns:a="http://schemas.openxmlformats.org/drawingml/2006/main" xmlns:r="http://schemas.openxmlformats.org/officeDocument/2006/relationships" xmlns:p="http://schemas.openxmlformats.org/presentationml/2006/main">
   <p:cSld>
     <p:bg>
       <p:bgPr>
@@ -19587,7 +20220,14 @@
         <p:cNvGrpSpPr/>
         <p:nvPr/>
       </p:nvGrpSpPr>
-      <p:grpSpPr/>
+      <p:grpSpPr>
+        <a:xfrm>
+          <a:off x="0" y="0"/>
+          <a:ext cx="0" cy="0"/>
+          <a:chOff x="0" y="0"/>
+          <a:chExt cx="0" cy="0"/>
+        </a:xfrm>
+      </p:grpSpPr>
       <p:sp>
         <p:nvSpPr>
           <p:cNvPr id="2" name="Rectangle 1"/>
@@ -19628,6 +20268,7 @@
           <a:lstStyle/>
           <a:p>
             <a:pPr algn="ctr"/>
+            <a:endParaRPr/>
           </a:p>
         </p:txBody>
       </p:sp>
@@ -19741,6 +20382,7 @@
           <a:lstStyle/>
           <a:p>
             <a:pPr algn="ctr"/>
+            <a:endParaRPr/>
           </a:p>
         </p:txBody>
       </p:sp>
@@ -19761,7 +20403,7 @@
           <a:noFill/>
         </p:spPr>
         <p:txBody>
-          <a:bodyPr wrap="square" lIns="0" rIns="0" tIns="0" bIns="0" anchor="t">
+          <a:bodyPr wrap="square" lIns="0" tIns="0" rIns="0" bIns="0" anchor="t">
             <a:spAutoFit/>
           </a:bodyPr>
           <a:lstStyle/>
@@ -19858,7 +20500,7 @@
 </file>
 
 <file path=ppt/slides/slide56.xml><?xml version="1.0" encoding="utf-8"?>
-<p:sld xmlns:a="http://schemas.openxmlformats.org/drawingml/2006/main" xmlns:p="http://schemas.openxmlformats.org/presentationml/2006/main" xmlns:r="http://schemas.openxmlformats.org/officeDocument/2006/relationships">
+<p:sld xmlns:a="http://schemas.openxmlformats.org/drawingml/2006/main" xmlns:r="http://schemas.openxmlformats.org/officeDocument/2006/relationships" xmlns:p="http://schemas.openxmlformats.org/presentationml/2006/main">
   <p:cSld>
     <p:bg>
       <p:bgPr>
@@ -19874,7 +20516,14 @@
         <p:cNvGrpSpPr/>
         <p:nvPr/>
       </p:nvGrpSpPr>
-      <p:grpSpPr/>
+      <p:grpSpPr>
+        <a:xfrm>
+          <a:off x="0" y="0"/>
+          <a:ext cx="0" cy="0"/>
+          <a:chOff x="0" y="0"/>
+          <a:chExt cx="0" cy="0"/>
+        </a:xfrm>
+      </p:grpSpPr>
       <p:sp>
         <p:nvSpPr>
           <p:cNvPr id="2" name="Rectangle 1"/>
@@ -19915,6 +20564,7 @@
           <a:lstStyle/>
           <a:p>
             <a:pPr algn="ctr"/>
+            <a:endParaRPr/>
           </a:p>
         </p:txBody>
       </p:sp>
@@ -20028,6 +20678,7 @@
           <a:lstStyle/>
           <a:p>
             <a:pPr algn="ctr"/>
+            <a:endParaRPr/>
           </a:p>
         </p:txBody>
       </p:sp>
@@ -20048,7 +20699,7 @@
           <a:noFill/>
         </p:spPr>
         <p:txBody>
-          <a:bodyPr wrap="square" lIns="0" rIns="0" tIns="0" bIns="0" anchor="t">
+          <a:bodyPr wrap="square" lIns="0" tIns="0" rIns="0" bIns="0" anchor="t">
             <a:spAutoFit/>
           </a:bodyPr>
           <a:lstStyle/>
@@ -20111,7 +20762,7 @@
 </file>
 
 <file path=ppt/slides/slide57.xml><?xml version="1.0" encoding="utf-8"?>
-<p:sld xmlns:a="http://schemas.openxmlformats.org/drawingml/2006/main" xmlns:p="http://schemas.openxmlformats.org/presentationml/2006/main" xmlns:r="http://schemas.openxmlformats.org/officeDocument/2006/relationships">
+<p:sld xmlns:a="http://schemas.openxmlformats.org/drawingml/2006/main" xmlns:r="http://schemas.openxmlformats.org/officeDocument/2006/relationships" xmlns:p="http://schemas.openxmlformats.org/presentationml/2006/main">
   <p:cSld>
     <p:bg>
       <p:bgPr>
@@ -20127,7 +20778,14 @@
         <p:cNvGrpSpPr/>
         <p:nvPr/>
       </p:nvGrpSpPr>
-      <p:grpSpPr/>
+      <p:grpSpPr>
+        <a:xfrm>
+          <a:off x="0" y="0"/>
+          <a:ext cx="0" cy="0"/>
+          <a:chOff x="0" y="0"/>
+          <a:chExt cx="0" cy="0"/>
+        </a:xfrm>
+      </p:grpSpPr>
       <p:sp>
         <p:nvSpPr>
           <p:cNvPr id="2" name="Rectangle 1"/>
@@ -20168,6 +20826,7 @@
           <a:lstStyle/>
           <a:p>
             <a:pPr algn="ctr"/>
+            <a:endParaRPr/>
           </a:p>
         </p:txBody>
       </p:sp>
@@ -20281,6 +20940,7 @@
           <a:lstStyle/>
           <a:p>
             <a:pPr algn="ctr"/>
+            <a:endParaRPr/>
           </a:p>
         </p:txBody>
       </p:sp>
@@ -20301,7 +20961,7 @@
           <a:noFill/>
         </p:spPr>
         <p:txBody>
-          <a:bodyPr wrap="square" lIns="0" rIns="0" tIns="0" bIns="0" anchor="t">
+          <a:bodyPr wrap="square" lIns="0" tIns="0" rIns="0" bIns="0" anchor="t">
             <a:spAutoFit/>
           </a:bodyPr>
           <a:lstStyle/>
@@ -20398,7 +21058,7 @@
 </file>
 
 <file path=ppt/slides/slide58.xml><?xml version="1.0" encoding="utf-8"?>
-<p:sld xmlns:a="http://schemas.openxmlformats.org/drawingml/2006/main" xmlns:p="http://schemas.openxmlformats.org/presentationml/2006/main" xmlns:r="http://schemas.openxmlformats.org/officeDocument/2006/relationships">
+<p:sld xmlns:a="http://schemas.openxmlformats.org/drawingml/2006/main" xmlns:r="http://schemas.openxmlformats.org/officeDocument/2006/relationships" xmlns:p="http://schemas.openxmlformats.org/presentationml/2006/main">
   <p:cSld>
     <p:bg>
       <p:bgPr>
@@ -20414,7 +21074,14 @@
         <p:cNvGrpSpPr/>
         <p:nvPr/>
       </p:nvGrpSpPr>
-      <p:grpSpPr/>
+      <p:grpSpPr>
+        <a:xfrm>
+          <a:off x="0" y="0"/>
+          <a:ext cx="0" cy="0"/>
+          <a:chOff x="0" y="0"/>
+          <a:chExt cx="0" cy="0"/>
+        </a:xfrm>
+      </p:grpSpPr>
       <p:sp>
         <p:nvSpPr>
           <p:cNvPr id="2" name="Rectangle 1"/>
@@ -20455,6 +21122,7 @@
           <a:lstStyle/>
           <a:p>
             <a:pPr algn="ctr"/>
+            <a:endParaRPr/>
           </a:p>
         </p:txBody>
       </p:sp>
@@ -20568,6 +21236,7 @@
           <a:lstStyle/>
           <a:p>
             <a:pPr algn="ctr"/>
+            <a:endParaRPr/>
           </a:p>
         </p:txBody>
       </p:sp>
@@ -20588,7 +21257,7 @@
           <a:noFill/>
         </p:spPr>
         <p:txBody>
-          <a:bodyPr wrap="square" lIns="0" rIns="0" tIns="0" bIns="0" anchor="t">
+          <a:bodyPr wrap="square" lIns="0" tIns="0" rIns="0" bIns="0" anchor="t">
             <a:spAutoFit/>
           </a:bodyPr>
           <a:lstStyle/>
@@ -20685,7 +21354,7 @@
 </file>
 
 <file path=ppt/slides/slide6.xml><?xml version="1.0" encoding="utf-8"?>
-<p:sld xmlns:a="http://schemas.openxmlformats.org/drawingml/2006/main" xmlns:p="http://schemas.openxmlformats.org/presentationml/2006/main" xmlns:r="http://schemas.openxmlformats.org/officeDocument/2006/relationships">
+<p:sld xmlns:a="http://schemas.openxmlformats.org/drawingml/2006/main" xmlns:r="http://schemas.openxmlformats.org/officeDocument/2006/relationships" xmlns:p="http://schemas.openxmlformats.org/presentationml/2006/main">
   <p:cSld>
     <p:bg>
       <p:bgPr>
@@ -20701,7 +21370,14 @@
         <p:cNvGrpSpPr/>
         <p:nvPr/>
       </p:nvGrpSpPr>
-      <p:grpSpPr/>
+      <p:grpSpPr>
+        <a:xfrm>
+          <a:off x="0" y="0"/>
+          <a:ext cx="0" cy="0"/>
+          <a:chOff x="0" y="0"/>
+          <a:chExt cx="0" cy="0"/>
+        </a:xfrm>
+      </p:grpSpPr>
       <p:sp>
         <p:nvSpPr>
           <p:cNvPr id="2" name="Rectangle 1"/>
@@ -20742,6 +21418,7 @@
           <a:lstStyle/>
           <a:p>
             <a:pPr algn="ctr"/>
+            <a:endParaRPr/>
           </a:p>
         </p:txBody>
       </p:sp>
@@ -20855,6 +21532,7 @@
           <a:lstStyle/>
           <a:p>
             <a:pPr algn="ctr"/>
+            <a:endParaRPr/>
           </a:p>
         </p:txBody>
       </p:sp>
@@ -20875,7 +21553,7 @@
           <a:noFill/>
         </p:spPr>
         <p:txBody>
-          <a:bodyPr wrap="square" lIns="0" rIns="0" tIns="0" bIns="0" anchor="t">
+          <a:bodyPr wrap="square" lIns="0" tIns="0" rIns="0" bIns="0" anchor="t">
             <a:spAutoFit/>
           </a:bodyPr>
           <a:lstStyle/>
@@ -20938,7 +21616,7 @@
 </file>
 
 <file path=ppt/slides/slide7.xml><?xml version="1.0" encoding="utf-8"?>
-<p:sld xmlns:a="http://schemas.openxmlformats.org/drawingml/2006/main" xmlns:p="http://schemas.openxmlformats.org/presentationml/2006/main" xmlns:r="http://schemas.openxmlformats.org/officeDocument/2006/relationships">
+<p:sld xmlns:a="http://schemas.openxmlformats.org/drawingml/2006/main" xmlns:r="http://schemas.openxmlformats.org/officeDocument/2006/relationships" xmlns:p="http://schemas.openxmlformats.org/presentationml/2006/main">
   <p:cSld>
     <p:bg>
       <p:bgPr>
@@ -20954,7 +21632,14 @@
         <p:cNvGrpSpPr/>
         <p:nvPr/>
       </p:nvGrpSpPr>
-      <p:grpSpPr/>
+      <p:grpSpPr>
+        <a:xfrm>
+          <a:off x="0" y="0"/>
+          <a:ext cx="0" cy="0"/>
+          <a:chOff x="0" y="0"/>
+          <a:chExt cx="0" cy="0"/>
+        </a:xfrm>
+      </p:grpSpPr>
       <p:sp>
         <p:nvSpPr>
           <p:cNvPr id="2" name="Rectangle 1"/>
@@ -20995,6 +21680,7 @@
           <a:lstStyle/>
           <a:p>
             <a:pPr algn="ctr"/>
+            <a:endParaRPr/>
           </a:p>
         </p:txBody>
       </p:sp>
@@ -21108,6 +21794,7 @@
           <a:lstStyle/>
           <a:p>
             <a:pPr algn="ctr"/>
+            <a:endParaRPr/>
           </a:p>
         </p:txBody>
       </p:sp>
@@ -21128,7 +21815,7 @@
           <a:noFill/>
         </p:spPr>
         <p:txBody>
-          <a:bodyPr wrap="square" lIns="0" rIns="0" tIns="0" bIns="0" anchor="t">
+          <a:bodyPr wrap="square" lIns="0" tIns="0" rIns="0" bIns="0" anchor="t">
             <a:spAutoFit/>
           </a:bodyPr>
           <a:lstStyle/>
@@ -21225,7 +21912,7 @@
 </file>
 
 <file path=ppt/slides/slide8.xml><?xml version="1.0" encoding="utf-8"?>
-<p:sld xmlns:a="http://schemas.openxmlformats.org/drawingml/2006/main" xmlns:p="http://schemas.openxmlformats.org/presentationml/2006/main" xmlns:r="http://schemas.openxmlformats.org/officeDocument/2006/relationships">
+<p:sld xmlns:a="http://schemas.openxmlformats.org/drawingml/2006/main" xmlns:r="http://schemas.openxmlformats.org/officeDocument/2006/relationships" xmlns:p="http://schemas.openxmlformats.org/presentationml/2006/main">
   <p:cSld>
     <p:bg>
       <p:bgPr>
@@ -21241,7 +21928,14 @@
         <p:cNvGrpSpPr/>
         <p:nvPr/>
       </p:nvGrpSpPr>
-      <p:grpSpPr/>
+      <p:grpSpPr>
+        <a:xfrm>
+          <a:off x="0" y="0"/>
+          <a:ext cx="0" cy="0"/>
+          <a:chOff x="0" y="0"/>
+          <a:chExt cx="0" cy="0"/>
+        </a:xfrm>
+      </p:grpSpPr>
       <p:sp>
         <p:nvSpPr>
           <p:cNvPr id="2" name="Rectangle 1"/>
@@ -21282,6 +21976,7 @@
           <a:lstStyle/>
           <a:p>
             <a:pPr algn="ctr"/>
+            <a:endParaRPr/>
           </a:p>
         </p:txBody>
       </p:sp>
@@ -21395,6 +22090,7 @@
           <a:lstStyle/>
           <a:p>
             <a:pPr algn="ctr"/>
+            <a:endParaRPr/>
           </a:p>
         </p:txBody>
       </p:sp>
@@ -21415,7 +22111,7 @@
           <a:noFill/>
         </p:spPr>
         <p:txBody>
-          <a:bodyPr wrap="square" lIns="0" rIns="0" tIns="0" bIns="0" anchor="t">
+          <a:bodyPr wrap="square" lIns="0" tIns="0" rIns="0" bIns="0" anchor="t">
             <a:spAutoFit/>
           </a:bodyPr>
           <a:lstStyle/>
@@ -21512,7 +22208,7 @@
 </file>
 
 <file path=ppt/slides/slide9.xml><?xml version="1.0" encoding="utf-8"?>
-<p:sld xmlns:a="http://schemas.openxmlformats.org/drawingml/2006/main" xmlns:p="http://schemas.openxmlformats.org/presentationml/2006/main" xmlns:r="http://schemas.openxmlformats.org/officeDocument/2006/relationships">
+<p:sld xmlns:a="http://schemas.openxmlformats.org/drawingml/2006/main" xmlns:r="http://schemas.openxmlformats.org/officeDocument/2006/relationships" xmlns:p="http://schemas.openxmlformats.org/presentationml/2006/main">
   <p:cSld>
     <p:bg>
       <p:bgPr>
@@ -21528,7 +22224,14 @@
         <p:cNvGrpSpPr/>
         <p:nvPr/>
       </p:nvGrpSpPr>
-      <p:grpSpPr/>
+      <p:grpSpPr>
+        <a:xfrm>
+          <a:off x="0" y="0"/>
+          <a:ext cx="0" cy="0"/>
+          <a:chOff x="0" y="0"/>
+          <a:chExt cx="0" cy="0"/>
+        </a:xfrm>
+      </p:grpSpPr>
       <p:sp>
         <p:nvSpPr>
           <p:cNvPr id="2" name="Rectangle 1"/>
@@ -21569,6 +22272,7 @@
           <a:lstStyle/>
           <a:p>
             <a:pPr algn="ctr"/>
+            <a:endParaRPr/>
           </a:p>
         </p:txBody>
       </p:sp>
@@ -21682,6 +22386,7 @@
           <a:lstStyle/>
           <a:p>
             <a:pPr algn="ctr"/>
+            <a:endParaRPr/>
           </a:p>
         </p:txBody>
       </p:sp>
@@ -21702,7 +22407,7 @@
           <a:noFill/>
         </p:spPr>
         <p:txBody>
-          <a:bodyPr wrap="square" lIns="0" rIns="0" tIns="0" bIns="0" anchor="t">
+          <a:bodyPr wrap="square" lIns="0" tIns="0" rIns="0" bIns="0" anchor="t">
             <a:spAutoFit/>
           </a:bodyPr>
           <a:lstStyle/>

</xml_diff>